<commit_message>
Drop a line from the data slide that the limitations slide already carries
The cross-study caveat about grey versus white matter appeared both under the
dataset table and as its own limitation, so the duplicate is removed. Also
ignores node_modules, lockfiles and logs, which the deck build pulls in.

Co-Authored-By: Claude Opus 4.8 <noreply@anthropic.com>
Claude-Session: https://claude.ai/code/session_01Puq8M8AiJGJDbdbxajvkZL
</commit_message>
<xml_diff>
--- a/results/mda5/MDA5_IFIH1_人脑与MS.pptx
+++ b/results/mda5/MDA5_IFIH1_人脑与MS.pptx
@@ -3894,45 +3894,6 @@
           </a:graphicData>
         </a:graphic>
       </p:graphicFrame>
-      <p:sp>
-        <p:nvSpPr>
-          <p:cNvPr id="5" name="Text 2"/>
-          <p:cNvSpPr txBox="1"/>
-          <p:nvPr/>
-        </p:nvSpPr>
-        <p:spPr>
-          <a:xfrm>
-            <a:off x="548640" y="4663440"/>
-            <a:ext cx="11064240" cy="365760"/>
-          </a:xfrm>
-          <a:prstGeom prst="rect">
-            <a:avLst/>
-          </a:prstGeom>
-          <a:noFill/>
-          <a:ln/>
-        </p:spPr>
-        <p:txBody>
-          <a:bodyPr wrap="square" lIns="0" tIns="0" rIns="0" bIns="0" rtlCol="0" anchor="ctr"/>
-          <a:lstStyle/>
-          <a:p>
-            <a:pPr indent="0" marL="0">
-              <a:buNone/>
-            </a:pPr>
-            <a:r>
-              <a:rPr lang="en-US" sz="1300" dirty="0">
-                <a:solidFill>
-                  <a:srgbClr val="6E6E6E"/>
-                </a:solidFill>
-                <a:latin typeface="Microsoft YaHei" pitchFamily="34" charset="0"/>
-                <a:ea typeface="Microsoft YaHei" pitchFamily="34" charset="-122"/>
-                <a:cs typeface="Microsoft YaHei" pitchFamily="34" charset="-120"/>
-              </a:rPr>
-              <a:t>灰质与白质分属不同研究：Macnair 2025 为唯一同时含两者的队列，存于 EGA 受控访问。</a:t>
-            </a:r>
-            <a:endParaRPr lang="en-US" sz="1300" dirty="0"/>
-          </a:p>
-        </p:txBody>
-      </p:sp>
     </p:spTree>
   </p:cSld>
   <p:clrMapOvr>

</xml_diff>

<commit_message>
Use standard cell-biology terminology and remove explanatory subtitles
Three changes to how the deck reads, none to what it claims.

Cell types now carry their full names: 少突胶质细胞, 小胶质细胞, 星形胶质细胞,
少突胶质前体细胞, 神经元, 内皮细胞. Lesion stages use pathology terms,
慢性活动性病灶边缘 and 病灶周围白质 rather than the shortened forms. The
measured quantity is stated as IFIH1 阳性核比例 rather than 检出率, intervals
as 95% 置信区间, and an unmeasurable cell is 对照组未检出 or 样本量不足 rather
than a statement about medians.

Every slide subtitle is gone. What the axes mean now lives on the axes.

The cross-study offset slide keeps only the percentile panel. The panel
showing the size of the offset was scaffolding for that percentile, not a
result, so it does not belong on a slide.

Co-Authored-By: Claude Opus 5 <noreply@anthropic.com>
Claude-Session: https://claude.ai/code/session_01Puq8M8AiJGJDbdbxajvkZL
</commit_message>
<xml_diff>
--- a/results/mda5/MDA5_IFIH1_人脑与MS.pptx
+++ b/results/mda5/MDA5_IFIH1_人脑与MS.pptx
@@ -1911,7 +1911,7 @@
               <a:buNone/>
             </a:pPr>
             <a:r>
-              <a:rPr lang="en-US" sz="1600" dirty="0">
+              <a:rPr lang="en-US" sz="1700" dirty="0">
                 <a:solidFill>
                   <a:srgbClr val="6E6E6E"/>
                 </a:solidFill>
@@ -1919,9 +1919,9 @@
                 <a:ea typeface="Microsoft YaHei" pitchFamily="34" charset="-122"/>
                 <a:cs typeface="Microsoft YaHei" pitchFamily="34" charset="-120"/>
               </a:rPr>
-              <a:t>全篇测量同一个量：单个核是否检出 IFIH1。细胞类型、区室、正常与 MS，只是分格的三条轴。</a:t>
+              <a:t>单核转录组水平的细胞类型特异性分析</a:t>
             </a:r>
-            <a:endParaRPr lang="en-US" sz="1600" dirty="0"/>
+            <a:endParaRPr lang="en-US" sz="1700" dirty="0"/>
           </a:p>
         </p:txBody>
       </p:sp>
@@ -2022,54 +2022,15 @@
                 <a:ea typeface="Microsoft YaHei" pitchFamily="34" charset="-122"/>
                 <a:cs typeface="Microsoft YaHei" pitchFamily="34" charset="-120"/>
               </a:rPr>
-              <a:t>白质内部：细胞图谱与病灶分期</a:t>
+              <a:t>白质单核图谱与脱髓鞘病灶分期</a:t>
             </a:r>
             <a:endParaRPr lang="en-US" sz="2500" dirty="0"/>
           </a:p>
         </p:txBody>
       </p:sp>
-      <p:sp>
-        <p:nvSpPr>
-          <p:cNvPr id="4" name="Text 2"/>
-          <p:cNvSpPr txBox="1"/>
-          <p:nvPr/>
-        </p:nvSpPr>
-        <p:spPr>
-          <a:xfrm>
-            <a:off x="548640" y="786384"/>
-            <a:ext cx="11064240" cy="329184"/>
-          </a:xfrm>
-          <a:prstGeom prst="rect">
-            <a:avLst/>
-          </a:prstGeom>
-          <a:noFill/>
-          <a:ln/>
-        </p:spPr>
-        <p:txBody>
-          <a:bodyPr wrap="square" lIns="0" tIns="0" rIns="0" bIns="0" rtlCol="0" anchor="ctr"/>
-          <a:lstStyle/>
-          <a:p>
-            <a:pPr indent="0" marL="0">
-              <a:buNone/>
-            </a:pPr>
-            <a:r>
-              <a:rPr lang="en-US" sz="1350" dirty="0">
-                <a:solidFill>
-                  <a:srgbClr val="6E6E6E"/>
-                </a:solidFill>
-                <a:latin typeface="Microsoft YaHei" pitchFamily="34" charset="0"/>
-                <a:ea typeface="Microsoft YaHei" pitchFamily="34" charset="-122"/>
-                <a:cs typeface="Microsoft YaHei" pitchFamily="34" charset="-120"/>
-              </a:rPr>
-              <a:t>GSE180759，66 432 个核，已按文库做 Harmony 整合。对照白质几乎不表达，慢性活动边缘在小胶质与少突胶质上点亮。</a:t>
-            </a:r>
-            <a:endParaRPr lang="en-US" sz="1350" dirty="0"/>
-          </a:p>
-        </p:txBody>
-      </p:sp>
       <p:pic>
         <p:nvPicPr>
-          <p:cNvPr id="5" name="Image 0" descr="/home/user/aaa/results/mda5/figs/fig_umap_wm.png">    </p:cNvPr>
+          <p:cNvPr id="4" name="Image 0" descr="/home/user/aaa/results/mda5/figs/fig_umap_wm.png">    </p:cNvPr>
           <p:cNvPicPr>
             <a:picLocks noChangeAspect="1"/>
           </p:cNvPicPr>
@@ -2083,8 +2044,8 @@
         </p:blipFill>
         <p:spPr>
           <a:xfrm>
-            <a:off x="426951" y="1188720"/>
-            <a:ext cx="11353339" cy="5285232"/>
+            <a:off x="411480" y="1067218"/>
+            <a:ext cx="11384280" cy="5299636"/>
           </a:xfrm>
           <a:prstGeom prst="rect">
             <a:avLst/>
@@ -2209,7 +2170,7 @@
           </p:nvPr>
         </p:nvGraphicFramePr>
         <p:xfrm>
-          <a:off x="548640" y="1115568"/>
+          <a:off x="548640" y="960120"/>
           <a:ext cx="11064240" cy="914400"/>
         </p:xfrm>
         <a:graphic>
@@ -2220,7 +2181,7 @@
                 <a:gridCol w="3108960"/>
                 <a:gridCol w="7955280"/>
               </a:tblGrid>
-              <a:tr h="640080">
+              <a:tr h="658368">
                 <a:tc>
                   <a:txBody>
                     <a:bodyPr/>
@@ -2238,7 +2199,7 @@
                           <a:ea typeface="Microsoft YaHei" pitchFamily="34" charset="-122"/>
                           <a:cs typeface="Microsoft YaHei" pitchFamily="34" charset="-120"/>
                         </a:rPr>
-                        <a:t>本次结果</a:t>
+                        <a:t>本研究结果</a:t>
                       </a:r>
                       <a:endParaRPr lang="en-US" sz="1250" dirty="0">
                         <a:latin typeface="Microsoft YaHei" charset="0"/>
@@ -2316,7 +2277,7 @@
                   </a:tcPr>
                 </a:tc>
               </a:tr>
-              <a:tr h="640080">
+              <a:tr h="658368">
                 <a:tc>
                   <a:txBody>
                     <a:bodyPr/>
@@ -2412,7 +2373,7 @@
                   </a:tcPr>
                 </a:tc>
               </a:tr>
-              <a:tr h="640080">
+              <a:tr h="658368">
                 <a:tc>
                   <a:txBody>
                     <a:bodyPr/>
@@ -2508,7 +2469,7 @@
                   </a:tcPr>
                 </a:tc>
               </a:tr>
-              <a:tr h="640080">
+              <a:tr h="658368">
                 <a:tc>
                   <a:txBody>
                     <a:bodyPr/>
@@ -2604,7 +2565,7 @@
                   </a:tcPr>
                 </a:tc>
               </a:tr>
-              <a:tr h="640080">
+              <a:tr h="658368">
                 <a:tc>
                   <a:txBody>
                     <a:bodyPr/>
@@ -2700,7 +2661,7 @@
                   </a:tcPr>
                 </a:tc>
               </a:tr>
-              <a:tr h="640080">
+              <a:tr h="658368">
                 <a:tc>
                   <a:txBody>
                     <a:bodyPr/>
@@ -2796,7 +2757,7 @@
                   </a:tcPr>
                 </a:tc>
               </a:tr>
-              <a:tr h="640080">
+              <a:tr h="658368">
                 <a:tc>
                   <a:txBody>
                     <a:bodyPr/>
@@ -2892,7 +2853,7 @@
                   </a:tcPr>
                 </a:tc>
               </a:tr>
-              <a:tr h="640080">
+              <a:tr h="658368">
                 <a:tc>
                   <a:txBody>
                     <a:bodyPr/>
@@ -3089,7 +3050,7 @@
                 <a:ea typeface="Microsoft YaHei" pitchFamily="34" charset="-122"/>
                 <a:cs typeface="Microsoft YaHei" pitchFamily="34" charset="-120"/>
               </a:rPr>
-              <a:t>限制</a:t>
+              <a:t>局限</a:t>
             </a:r>
             <a:endParaRPr lang="en-US" sz="2500" dirty="0"/>
           </a:p>
@@ -3103,7 +3064,7 @@
         </p:nvSpPr>
         <p:spPr>
           <a:xfrm>
-            <a:off x="548640" y="1115568"/>
+            <a:off x="548640" y="1005840"/>
             <a:ext cx="3566160" cy="365760"/>
           </a:xfrm>
           <a:prstGeom prst="rect">
@@ -3128,7 +3089,7 @@
                 <a:ea typeface="Microsoft YaHei" pitchFamily="34" charset="-122"/>
                 <a:cs typeface="Microsoft YaHei" pitchFamily="34" charset="-120"/>
               </a:rPr>
-              <a:t>皮层侧不是纯灰质</a:t>
+              <a:t>皮层标本含白质成分</a:t>
             </a:r>
             <a:endParaRPr lang="en-US" sz="1350" dirty="0"/>
           </a:p>
@@ -3142,7 +3103,7 @@
         </p:nvSpPr>
         <p:spPr>
           <a:xfrm>
-            <a:off x="4251960" y="1115568"/>
+            <a:off x="4251960" y="1005840"/>
             <a:ext cx="7406640" cy="566928"/>
           </a:xfrm>
           <a:prstGeom prst="rect">
@@ -3170,7 +3131,7 @@
                 <a:ea typeface="Microsoft YaHei" pitchFamily="34" charset="-122"/>
                 <a:cs typeface="Microsoft YaHei" pitchFamily="34" charset="-120"/>
               </a:rPr>
-              <a:t>Schirmer 组织块含皮层下白质，且 MS 块的白质成分显著多于对照块，该侧的疾病对比与解剖深度混杂。</a:t>
+              <a:t>Schirmer 取材跨越皮层全层并带有其下的皮层下白质，MS 标本取材更深，疾病对比与取材部位混杂。</a:t>
             </a:r>
             <a:endParaRPr lang="en-US" sz="1200" dirty="0"/>
           </a:p>
@@ -3184,7 +3145,7 @@
         </p:nvSpPr>
         <p:spPr>
           <a:xfrm>
-            <a:off x="548640" y="1847088"/>
+            <a:off x="548640" y="1737360"/>
             <a:ext cx="3566160" cy="365760"/>
           </a:xfrm>
           <a:prstGeom prst="rect">
@@ -3209,7 +3170,7 @@
                 <a:ea typeface="Microsoft YaHei" pitchFamily="34" charset="-122"/>
                 <a:cs typeface="Microsoft YaHei" pitchFamily="34" charset="-120"/>
               </a:rPr>
-              <a:t>交互项只有两类可估计</a:t>
+              <a:t>区域交互仅两类可估计</a:t>
             </a:r>
             <a:endParaRPr lang="en-US" sz="1350" dirty="0"/>
           </a:p>
@@ -3223,7 +3184,7 @@
         </p:nvSpPr>
         <p:spPr>
           <a:xfrm>
-            <a:off x="4251960" y="1847088"/>
+            <a:off x="4251960" y="1737360"/>
             <a:ext cx="7406640" cy="566928"/>
           </a:xfrm>
           <a:prstGeom prst="rect">
@@ -3251,7 +3212,7 @@
                 <a:ea typeface="Microsoft YaHei" pitchFamily="34" charset="-122"/>
                 <a:cs typeface="Microsoft YaHei" pitchFamily="34" charset="-120"/>
               </a:rPr>
-              <a:t>小胶质、神经元、内皮因一侧供体不足，OPC 因对照中位为零。两类可估计者区间均触及零。</a:t>
+              <a:t>小胶质细胞、神经元、内皮细胞因一侧样本量不足，少突胶质前体细胞因对照组未检出。</a:t>
             </a:r>
             <a:endParaRPr lang="en-US" sz="1200" dirty="0"/>
           </a:p>
@@ -3265,7 +3226,7 @@
         </p:nvSpPr>
         <p:spPr>
           <a:xfrm>
-            <a:off x="548640" y="2578608"/>
+            <a:off x="548640" y="2468880"/>
             <a:ext cx="3566160" cy="365760"/>
           </a:xfrm>
           <a:prstGeom prst="rect">
@@ -3290,7 +3251,7 @@
                 <a:ea typeface="Microsoft YaHei" pitchFamily="34" charset="-122"/>
                 <a:cs typeface="Microsoft YaHei" pitchFamily="34" charset="-120"/>
               </a:rPr>
-              <a:t>白质结论主要由一个队列承担</a:t>
+              <a:t>白质结论主要由一个队列支持</a:t>
             </a:r>
             <a:endParaRPr lang="en-US" sz="1350" dirty="0"/>
           </a:p>
@@ -3304,7 +3265,7 @@
         </p:nvSpPr>
         <p:spPr>
           <a:xfrm>
-            <a:off x="4251960" y="2578608"/>
+            <a:off x="4251960" y="2468880"/>
             <a:ext cx="7406640" cy="566928"/>
           </a:xfrm>
           <a:prstGeom prst="rect">
@@ -3332,7 +3293,7 @@
                 <a:ea typeface="Microsoft YaHei" pitchFamily="34" charset="-122"/>
                 <a:cs typeface="Microsoft YaHei" pitchFamily="34" charset="-120"/>
               </a:rPr>
-              <a:t>GSE279180 十三位供体，3.5 倍，区间 [1.5, 4.9]；GSE180759 仅三位对照，1.5 倍，区间跨 1。</a:t>
+              <a:t>GSE279180 十三例供体，3.5 倍，区间 [1.5, 4.9]；GSE180759 仅三例对照，1.5 倍，区间包含 1。</a:t>
             </a:r>
             <a:endParaRPr lang="en-US" sz="1200" dirty="0"/>
           </a:p>
@@ -3346,7 +3307,7 @@
         </p:nvSpPr>
         <p:spPr>
           <a:xfrm>
-            <a:off x="548640" y="3310128"/>
+            <a:off x="548640" y="3200400"/>
             <a:ext cx="3566160" cy="365760"/>
           </a:xfrm>
           <a:prstGeom prst="rect">
@@ -3371,7 +3332,7 @@
                 <a:ea typeface="Microsoft YaHei" pitchFamily="34" charset="-122"/>
                 <a:cs typeface="Microsoft YaHei" pitchFamily="34" charset="-120"/>
               </a:rPr>
-              <a:t>检出率仍随深度变化</a:t>
+              <a:t>测序深度残余影响</a:t>
             </a:r>
             <a:endParaRPr lang="en-US" sz="1350" dirty="0"/>
           </a:p>
@@ -3385,7 +3346,7 @@
         </p:nvSpPr>
         <p:spPr>
           <a:xfrm>
-            <a:off x="4251960" y="3310128"/>
+            <a:off x="4251960" y="3200400"/>
             <a:ext cx="7406640" cy="566928"/>
           </a:xfrm>
           <a:prstGeom prst="rect">
@@ -3413,7 +3374,7 @@
                 <a:ea typeface="Microsoft YaHei" pitchFamily="34" charset="-122"/>
                 <a:cs typeface="Microsoft YaHei" pitchFamily="34" charset="-120"/>
               </a:rPr>
-              <a:t>已限定在每核 1500 至 5000 UMI 的共同区间内比较，但区间内仍有残余深度差异。</a:t>
+              <a:t>已限定在每核 1500 至 5000 UMI 的共同深度区间内比较，区间内仍存在残余差异。</a:t>
             </a:r>
             <a:endParaRPr lang="en-US" sz="1200" dirty="0"/>
           </a:p>
@@ -3427,7 +3388,7 @@
         </p:nvSpPr>
         <p:spPr>
           <a:xfrm>
-            <a:off x="548640" y="4041648"/>
+            <a:off x="548640" y="3931920"/>
             <a:ext cx="3566160" cy="365760"/>
           </a:xfrm>
           <a:prstGeom prst="rect">
@@ -3466,7 +3427,7 @@
         </p:nvSpPr>
         <p:spPr>
           <a:xfrm>
-            <a:off x="4251960" y="4041648"/>
+            <a:off x="4251960" y="3931920"/>
             <a:ext cx="7406640" cy="566928"/>
           </a:xfrm>
           <a:prstGeom prst="rect">
@@ -3494,7 +3455,7 @@
                 <a:ea typeface="Microsoft YaHei" pitchFamily="34" charset="-122"/>
                 <a:cs typeface="Microsoft YaHei" pitchFamily="34" charset="-120"/>
               </a:rPr>
-              <a:t>斑块周围文库全为 NovaSeq，病灶边缘文库全为 HiSeq；图谱已按文库做 Harmony 整合。</a:t>
+              <a:t>病灶周围白质文库全为 NovaSeq，病灶边缘文库全为 HiSeq；图谱已按文库做 Harmony 整合。</a:t>
             </a:r>
             <a:endParaRPr lang="en-US" sz="1200" dirty="0"/>
           </a:p>
@@ -3508,7 +3469,7 @@
         </p:nvSpPr>
         <p:spPr>
           <a:xfrm>
-            <a:off x="548640" y="4773168"/>
+            <a:off x="548640" y="4663440"/>
             <a:ext cx="3566160" cy="365760"/>
           </a:xfrm>
           <a:prstGeom prst="rect">
@@ -3533,7 +3494,7 @@
                 <a:ea typeface="Microsoft YaHei" pitchFamily="34" charset="-122"/>
                 <a:cs typeface="Microsoft YaHei" pitchFamily="34" charset="-120"/>
               </a:rPr>
-              <a:t>不用表达量而用检出率</a:t>
+              <a:t>以阳性核比例而非表达量</a:t>
             </a:r>
             <a:endParaRPr lang="en-US" sz="1350" dirty="0"/>
           </a:p>
@@ -3547,7 +3508,7 @@
         </p:nvSpPr>
         <p:spPr>
           <a:xfrm>
-            <a:off x="4251960" y="4773168"/>
+            <a:off x="4251960" y="4663440"/>
             <a:ext cx="7406640" cy="566928"/>
           </a:xfrm>
           <a:prstGeom prst="rect">
@@ -3575,7 +3536,7 @@
                 <a:ea typeface="Microsoft YaHei" pitchFamily="34" charset="-122"/>
                 <a:cs typeface="Microsoft YaHei" pitchFamily="34" charset="-120"/>
               </a:rPr>
-              <a:t>Schirmer 仅有对数归一化矩阵，尺度因子无法反解，跨队列的表达量不可比；检出与否不受归一化影响。</a:t>
+              <a:t>Schirmer 仅提供对数归一化矩阵，标度因子不可恢复，跨队列表达量不可比。</a:t>
             </a:r>
             <a:endParaRPr lang="en-US" sz="1200" dirty="0"/>
           </a:p>
@@ -3589,7 +3550,7 @@
         </p:nvSpPr>
         <p:spPr>
           <a:xfrm>
-            <a:off x="548640" y="5504688"/>
+            <a:off x="548640" y="5394960"/>
             <a:ext cx="3566160" cy="365760"/>
           </a:xfrm>
           <a:prstGeom prst="rect">
@@ -3614,7 +3575,7 @@
                 <a:ea typeface="Microsoft YaHei" pitchFamily="34" charset="-122"/>
                 <a:cs typeface="Microsoft YaHei" pitchFamily="34" charset="-120"/>
               </a:rPr>
-              <a:t>全部为转录本层面</a:t>
+              <a:t>仅限转录本水平</a:t>
             </a:r>
             <a:endParaRPr lang="en-US" sz="1350" dirty="0"/>
           </a:p>
@@ -3628,7 +3589,7 @@
         </p:nvSpPr>
         <p:spPr>
           <a:xfrm>
-            <a:off x="4251960" y="5504688"/>
+            <a:off x="4251960" y="5394960"/>
             <a:ext cx="7406640" cy="566928"/>
           </a:xfrm>
           <a:prstGeom prst="rect">
@@ -3656,7 +3617,7 @@
                 <a:ea typeface="Microsoft YaHei" pitchFamily="34" charset="-122"/>
                 <a:cs typeface="Microsoft YaHei" pitchFamily="34" charset="-120"/>
               </a:rPr>
-              <a:t>人类 MS 脑组织无任何 MDA5 蛋白测量。</a:t>
+              <a:t>人类 MS 脑组织尚无 MDA5 蛋白水平的测量。</a:t>
             </a:r>
             <a:endParaRPr lang="en-US" sz="1200" dirty="0"/>
           </a:p>
@@ -3798,7 +3759,7 @@
                 <a:ea typeface="Microsoft YaHei" pitchFamily="34" charset="-122"/>
                 <a:cs typeface="Microsoft YaHei" pitchFamily="34" charset="-120"/>
               </a:rPr>
-              <a:t>一　正常人脑中 IFIH1 由哪些细胞表达？灰质与白质是否不同？</a:t>
+              <a:t>一　正常人脑中 IFIH1 由哪些细胞类型表达？两个解剖区域是否不同？</a:t>
             </a:r>
             <a:endParaRPr lang="en-US" sz="1700" dirty="0"/>
           </a:p>
@@ -3837,48 +3798,9 @@
                 <a:ea typeface="Microsoft YaHei" pitchFamily="34" charset="-122"/>
                 <a:cs typeface="Microsoft YaHei" pitchFamily="34" charset="-120"/>
               </a:rPr>
-              <a:t>二　MS 中 IFIH1 的分布如何改变？灰质与白质的改变是否相同？</a:t>
+              <a:t>二　MS 病变中 IFIH1 的细胞分布如何改变？两个区域的改变是否相同？</a:t>
             </a:r>
             <a:endParaRPr lang="en-US" sz="1700" dirty="0"/>
-          </a:p>
-        </p:txBody>
-      </p:sp>
-      <p:sp>
-        <p:nvSpPr>
-          <p:cNvPr id="6" name="Text 4"/>
-          <p:cNvSpPr txBox="1"/>
-          <p:nvPr/>
-        </p:nvSpPr>
-        <p:spPr>
-          <a:xfrm>
-            <a:off x="685800" y="1883664"/>
-            <a:ext cx="10972800" cy="329184"/>
-          </a:xfrm>
-          <a:prstGeom prst="rect">
-            <a:avLst/>
-          </a:prstGeom>
-          <a:noFill/>
-          <a:ln/>
-        </p:spPr>
-        <p:txBody>
-          <a:bodyPr wrap="square" lIns="0" tIns="0" rIns="0" bIns="0" rtlCol="0" anchor="ctr"/>
-          <a:lstStyle/>
-          <a:p>
-            <a:pPr indent="0" marL="0">
-              <a:buNone/>
-            </a:pPr>
-            <a:r>
-              <a:rPr lang="en-US" sz="1300" dirty="0">
-                <a:solidFill>
-                  <a:srgbClr val="6E6E6E"/>
-                </a:solidFill>
-                <a:latin typeface="Microsoft YaHei" pitchFamily="34" charset="0"/>
-                <a:ea typeface="Microsoft YaHei" pitchFamily="34" charset="-122"/>
-                <a:cs typeface="Microsoft YaHei" pitchFamily="34" charset="-120"/>
-              </a:rPr>
-              <a:t>口径：每核是否检出 IFIH1，限定在三队列共有的测序深度区间（每核 1500 至 5000 UMI）内比较。该量在任何归一化下都精确，故三队列可比。</a:t>
-            </a:r>
-            <a:endParaRPr lang="en-US" sz="1300" dirty="0"/>
           </a:p>
         </p:txBody>
       </p:sp>
@@ -3897,7 +3819,7 @@
           </p:nvPr>
         </p:nvGraphicFramePr>
         <p:xfrm>
-          <a:off x="548640" y="2395728"/>
+          <a:off x="548640" y="2011680"/>
           <a:ext cx="11064240" cy="914400"/>
         </p:xfrm>
         <a:graphic>
@@ -3911,7 +3833,7 @@
                 <a:gridCol w="1463040"/>
                 <a:gridCol w="1828800"/>
               </a:tblGrid>
-              <a:tr h="566928">
+              <a:tr h="585216">
                 <a:tc>
                   <a:txBody>
                     <a:bodyPr/>
@@ -4148,7 +4070,7 @@
                   </a:tcPr>
                 </a:tc>
               </a:tr>
-              <a:tr h="566928">
+              <a:tr h="585216">
                 <a:tc>
                   <a:txBody>
                     <a:bodyPr/>
@@ -4354,7 +4276,7 @@
                           <a:ea typeface="Microsoft YaHei" pitchFamily="34" charset="-122"/>
                           <a:cs typeface="Microsoft YaHei" pitchFamily="34" charset="-120"/>
                         </a:rPr>
-                        <a:t>问题一：细胞类型次序</a:t>
+                        <a:t>细胞类型表达谱</a:t>
                       </a:r>
                       <a:endParaRPr lang="en-US" sz="1250" dirty="0">
                         <a:latin typeface="Microsoft YaHei" charset="0"/>
@@ -4385,7 +4307,7 @@
                   </a:tcPr>
                 </a:tc>
               </a:tr>
-              <a:tr h="566928">
+              <a:tr h="585216">
                 <a:tc>
                   <a:txBody>
                     <a:bodyPr/>
@@ -4591,7 +4513,7 @@
                           <a:ea typeface="Microsoft YaHei" pitchFamily="34" charset="-122"/>
                           <a:cs typeface="Microsoft YaHei" pitchFamily="34" charset="-120"/>
                         </a:rPr>
-                        <a:t>白质基线与改变</a:t>
+                        <a:t>白质，含病灶分期</a:t>
                       </a:r>
                       <a:endParaRPr lang="en-US" sz="1250" dirty="0">
                         <a:latin typeface="Microsoft YaHei" charset="0"/>
@@ -4622,7 +4544,7 @@
                   </a:tcPr>
                 </a:tc>
               </a:tr>
-              <a:tr h="566928">
+              <a:tr h="585216">
                 <a:tc>
                   <a:txBody>
                     <a:bodyPr/>
@@ -4828,7 +4750,7 @@
                           <a:ea typeface="Microsoft YaHei" pitchFamily="34" charset="-122"/>
                           <a:cs typeface="Microsoft YaHei" pitchFamily="34" charset="-120"/>
                         </a:rPr>
-                        <a:t>白质基线与改变（主力）</a:t>
+                        <a:t>白质，主队列</a:t>
                       </a:r>
                       <a:endParaRPr lang="en-US" sz="1250" dirty="0">
                         <a:latin typeface="Microsoft YaHei" charset="0"/>
@@ -4859,7 +4781,7 @@
                   </a:tcPr>
                 </a:tc>
               </a:tr>
-              <a:tr h="566928">
+              <a:tr h="585216">
                 <a:tc>
                   <a:txBody>
                     <a:bodyPr/>
@@ -4924,7 +4846,7 @@
                           <a:ea typeface="Microsoft YaHei" pitchFamily="34" charset="-122"/>
                           <a:cs typeface="Microsoft YaHei" pitchFamily="34" charset="-120"/>
                         </a:rPr>
-                        <a:t>皮层组织块（含皮层下白质）</a:t>
+                        <a:t>皮层标本</a:t>
                       </a:r>
                       <a:endParaRPr lang="en-US" sz="1250" dirty="0">
                         <a:latin typeface="Microsoft YaHei" charset="0"/>
@@ -5065,7 +4987,7 @@
                           <a:ea typeface="Microsoft YaHei" pitchFamily="34" charset="-122"/>
                           <a:cs typeface="Microsoft YaHei" pitchFamily="34" charset="-120"/>
                         </a:rPr>
-                        <a:t>皮层侧基线与改变</a:t>
+                        <a:t>皮层</a:t>
                       </a:r>
                       <a:endParaRPr lang="en-US" sz="1250" dirty="0">
                         <a:latin typeface="Microsoft YaHei" charset="0"/>
@@ -5096,7 +5018,7 @@
                   </a:tcPr>
                 </a:tc>
               </a:tr>
-              <a:tr h="566928">
+              <a:tr h="585216">
                 <a:tc>
                   <a:txBody>
                     <a:bodyPr/>
@@ -5302,7 +5224,7 @@
                           <a:ea typeface="Microsoft YaHei" pitchFamily="34" charset="-122"/>
                           <a:cs typeface="Microsoft YaHei" pitchFamily="34" charset="-120"/>
                         </a:rPr>
-                        <a:t>白质验证</a:t>
+                        <a:t>白质，验证</a:t>
                       </a:r>
                       <a:endParaRPr lang="en-US" sz="1250" dirty="0">
                         <a:latin typeface="Microsoft YaHei" charset="0"/>
@@ -5434,54 +5356,15 @@
                 <a:ea typeface="Microsoft YaHei" pitchFamily="34" charset="-122"/>
                 <a:cs typeface="Microsoft YaHei" pitchFamily="34" charset="-120"/>
               </a:rPr>
-              <a:t>问题一：IFIH1 由哪些细胞表达</a:t>
+              <a:t>IFIH1 在人脑各类细胞中的表达</a:t>
             </a:r>
             <a:endParaRPr lang="en-US" sz="2500" dirty="0"/>
           </a:p>
         </p:txBody>
       </p:sp>
-      <p:sp>
-        <p:nvSpPr>
-          <p:cNvPr id="4" name="Text 2"/>
-          <p:cNvSpPr txBox="1"/>
-          <p:nvPr/>
-        </p:nvSpPr>
-        <p:spPr>
-          <a:xfrm>
-            <a:off x="548640" y="786384"/>
-            <a:ext cx="11064240" cy="329184"/>
-          </a:xfrm>
-          <a:prstGeom prst="rect">
-            <a:avLst/>
-          </a:prstGeom>
-          <a:noFill/>
-          <a:ln/>
-        </p:spPr>
-        <p:txBody>
-          <a:bodyPr wrap="square" lIns="0" tIns="0" rIns="0" bIns="0" rtlCol="0" anchor="ctr"/>
-          <a:lstStyle/>
-          <a:p>
-            <a:pPr indent="0" marL="0">
-              <a:buNone/>
-            </a:pPr>
-            <a:r>
-              <a:rPr lang="en-US" sz="1350" dirty="0">
-                <a:solidFill>
-                  <a:srgbClr val="6E6E6E"/>
-                </a:solidFill>
-                <a:latin typeface="Microsoft YaHei" pitchFamily="34" charset="0"/>
-                <a:ea typeface="Microsoft YaHei" pitchFamily="34" charset="-122"/>
-                <a:cs typeface="Microsoft YaHei" pitchFamily="34" charset="-120"/>
-              </a:rPr>
-              <a:t>正常脑内 IFIH1 最高的是内皮，其次小胶质；神经元最低。左为 783 位供体的伪整体排序，右为白质单核层面的检出。</a:t>
-            </a:r>
-            <a:endParaRPr lang="en-US" sz="1350" dirty="0"/>
-          </a:p>
-        </p:txBody>
-      </p:sp>
       <p:pic>
         <p:nvPicPr>
-          <p:cNvPr id="5" name="Image 0" descr="/home/user/aaa/results/mda5/figs/fig_q1_celltype.png">    </p:cNvPr>
+          <p:cNvPr id="4" name="Image 0" descr="/home/user/aaa/results/mda5/figs/fig_q1_celltype.png">    </p:cNvPr>
           <p:cNvPicPr>
             <a:picLocks noChangeAspect="1"/>
           </p:cNvPicPr>
@@ -5495,8 +5378,8 @@
         </p:blipFill>
         <p:spPr>
           <a:xfrm>
-            <a:off x="411480" y="1489179"/>
-            <a:ext cx="11384280" cy="4684314"/>
+            <a:off x="411480" y="1429127"/>
+            <a:ext cx="11384280" cy="4575817"/>
           </a:xfrm>
           <a:prstGeom prst="rect">
             <a:avLst/>
@@ -5600,54 +5483,15 @@
                 <a:ea typeface="Microsoft YaHei" pitchFamily="34" charset="-122"/>
                 <a:cs typeface="Microsoft YaHei" pitchFamily="34" charset="-120"/>
               </a:rPr>
-              <a:t>问题一：正常人的两个区室</a:t>
+              <a:t>正常脑：两个解剖区域无差异</a:t>
             </a:r>
             <a:endParaRPr lang="en-US" sz="2500" dirty="0"/>
           </a:p>
         </p:txBody>
       </p:sp>
-      <p:sp>
-        <p:nvSpPr>
-          <p:cNvPr id="4" name="Text 2"/>
-          <p:cNvSpPr txBox="1"/>
-          <p:nvPr/>
-        </p:nvSpPr>
-        <p:spPr>
-          <a:xfrm>
-            <a:off x="548640" y="786384"/>
-            <a:ext cx="11064240" cy="329184"/>
-          </a:xfrm>
-          <a:prstGeom prst="rect">
-            <a:avLst/>
-          </a:prstGeom>
-          <a:noFill/>
-          <a:ln/>
-        </p:spPr>
-        <p:txBody>
-          <a:bodyPr wrap="square" lIns="0" tIns="0" rIns="0" bIns="0" rtlCol="0" anchor="ctr"/>
-          <a:lstStyle/>
-          <a:p>
-            <a:pPr indent="0" marL="0">
-              <a:buNone/>
-            </a:pPr>
-            <a:r>
-              <a:rPr lang="en-US" sz="1350" dirty="0">
-                <a:solidFill>
-                  <a:srgbClr val="6E6E6E"/>
-                </a:solidFill>
-                <a:latin typeface="Microsoft YaHei" pitchFamily="34" charset="0"/>
-                <a:ea typeface="Microsoft YaHei" pitchFamily="34" charset="-122"/>
-                <a:cs typeface="Microsoft YaHei" pitchFamily="34" charset="-120"/>
-              </a:rPr>
-              <a:t>只取对照供体。六类细胞在皮层下白质与皮层组织块之间均无显著差别。</a:t>
-            </a:r>
-            <a:endParaRPr lang="en-US" sz="1350" dirty="0"/>
-          </a:p>
-        </p:txBody>
-      </p:sp>
       <p:pic>
         <p:nvPicPr>
-          <p:cNvPr id="5" name="Image 0" descr="/home/user/aaa/results/mda5/figs/fig_q1_region.png">    </p:cNvPr>
+          <p:cNvPr id="4" name="Image 0" descr="/home/user/aaa/results/mda5/figs/fig_q1_region.png">    </p:cNvPr>
           <p:cNvPicPr>
             <a:picLocks noChangeAspect="1"/>
           </p:cNvPicPr>
@@ -5661,8 +5505,8 @@
         </p:blipFill>
         <p:spPr>
           <a:xfrm>
-            <a:off x="1061602" y="1188720"/>
-            <a:ext cx="10084036" cy="5285232"/>
+            <a:off x="841895" y="960120"/>
+            <a:ext cx="10523449" cy="5513832"/>
           </a:xfrm>
           <a:prstGeom prst="rect">
             <a:avLst/>
@@ -5766,54 +5610,15 @@
                 <a:ea typeface="Microsoft YaHei" pitchFamily="34" charset="-122"/>
                 <a:cs typeface="Microsoft YaHei" pitchFamily="34" charset="-120"/>
               </a:rPr>
-              <a:t>第 4 页的批次对照：把跨研究偏移扣掉</a:t>
+              <a:t>跨研究偏移的稳健性检验</a:t>
             </a:r>
             <a:endParaRPr lang="en-US" sz="2500" dirty="0"/>
           </a:p>
         </p:txBody>
       </p:sp>
-      <p:sp>
-        <p:nvSpPr>
-          <p:cNvPr id="4" name="Text 2"/>
-          <p:cNvSpPr txBox="1"/>
-          <p:nvPr/>
-        </p:nvSpPr>
-        <p:spPr>
-          <a:xfrm>
-            <a:off x="548640" y="786384"/>
-            <a:ext cx="11064240" cy="329184"/>
-          </a:xfrm>
-          <a:prstGeom prst="rect">
-            <a:avLst/>
-          </a:prstGeom>
-          <a:noFill/>
-          <a:ln/>
-        </p:spPr>
-        <p:txBody>
-          <a:bodyPr wrap="square" lIns="0" tIns="0" rIns="0" bIns="0" rtlCol="0" anchor="ctr"/>
-          <a:lstStyle/>
-          <a:p>
-            <a:pPr indent="0" marL="0">
-              <a:buNone/>
-            </a:pPr>
-            <a:r>
-              <a:rPr lang="en-US" sz="1350" dirty="0">
-                <a:solidFill>
-                  <a:srgbClr val="6E6E6E"/>
-                </a:solidFill>
-                <a:latin typeface="Microsoft YaHei" pitchFamily="34" charset="0"/>
-                <a:ea typeface="Microsoft YaHei" pitchFamily="34" charset="-122"/>
-                <a:cs typeface="Microsoft YaHei" pitchFamily="34" charset="-120"/>
-              </a:rPr>
-              <a:t>偏移同等作用于所有基因，故全基因组 log2（白质/灰质）的中位即偏移量。扣掉它之后，只有星形胶质在两个白质队列中都高于中位。</a:t>
-            </a:r>
-            <a:endParaRPr lang="en-US" sz="1350" dirty="0"/>
-          </a:p>
-        </p:txBody>
-      </p:sp>
       <p:pic>
         <p:nvPicPr>
-          <p:cNvPr id="5" name="Image 0" descr="/home/user/aaa/results/mda5/figs/figB_null.png">    </p:cNvPr>
+          <p:cNvPr id="4" name="Image 0" descr="/home/user/aaa/results/mda5/figs/figB_null.png">    </p:cNvPr>
           <p:cNvPicPr>
             <a:picLocks noChangeAspect="1"/>
           </p:cNvPicPr>
@@ -5827,8 +5632,8 @@
         </p:blipFill>
         <p:spPr>
           <a:xfrm>
-            <a:off x="803887" y="1316736"/>
-            <a:ext cx="10599466" cy="5157216"/>
+            <a:off x="963367" y="960120"/>
+            <a:ext cx="10280507" cy="5513832"/>
           </a:xfrm>
           <a:prstGeom prst="rect">
             <a:avLst/>
@@ -5932,54 +5737,15 @@
                 <a:ea typeface="Microsoft YaHei" pitchFamily="34" charset="-122"/>
                 <a:cs typeface="Microsoft YaHei" pitchFamily="34" charset="-120"/>
               </a:rPr>
-              <a:t>问题二：皮层下白质中，MS 相对对照的改变</a:t>
+              <a:t>MS 白质：少突胶质细胞 IFIH1 阳性率升高</a:t>
             </a:r>
             <a:endParaRPr lang="en-US" sz="2500" dirty="0"/>
           </a:p>
         </p:txBody>
       </p:sp>
-      <p:sp>
-        <p:nvSpPr>
-          <p:cNvPr id="4" name="Text 2"/>
-          <p:cNvSpPr txBox="1"/>
-          <p:nvPr/>
-        </p:nvSpPr>
-        <p:spPr>
-          <a:xfrm>
-            <a:off x="548640" y="786384"/>
-            <a:ext cx="11064240" cy="329184"/>
-          </a:xfrm>
-          <a:prstGeom prst="rect">
-            <a:avLst/>
-          </a:prstGeom>
-          <a:noFill/>
-          <a:ln/>
-        </p:spPr>
-        <p:txBody>
-          <a:bodyPr wrap="square" lIns="0" tIns="0" rIns="0" bIns="0" rtlCol="0" anchor="ctr"/>
-          <a:lstStyle/>
-          <a:p>
-            <a:pPr indent="0" marL="0">
-              <a:buNone/>
-            </a:pPr>
-            <a:r>
-              <a:rPr lang="en-US" sz="1350" dirty="0">
-                <a:solidFill>
-                  <a:srgbClr val="6E6E6E"/>
-                </a:solidFill>
-                <a:latin typeface="Microsoft YaHei" pitchFamily="34" charset="0"/>
-                <a:ea typeface="Microsoft YaHei" pitchFamily="34" charset="-122"/>
-                <a:cs typeface="Microsoft YaHei" pitchFamily="34" charset="-120"/>
-              </a:rPr>
-              <a:t>两个队列分开计算，每点一位供体，括号内为倍数变化的自助 95% 区间。少突胶质两队列同向升高，GSE279180 达 3.5 倍且区间不跨 1。</a:t>
-            </a:r>
-            <a:endParaRPr lang="en-US" sz="1350" dirty="0"/>
-          </a:p>
-        </p:txBody>
-      </p:sp>
       <p:pic>
         <p:nvPicPr>
-          <p:cNvPr id="5" name="Image 0" descr="/home/user/aaa/results/mda5/figs/fig_q2_wm.png">    </p:cNvPr>
+          <p:cNvPr id="4" name="Image 0" descr="/home/user/aaa/results/mda5/figs/fig_q2_wm.png">    </p:cNvPr>
           <p:cNvPicPr>
             <a:picLocks noChangeAspect="1"/>
           </p:cNvPicPr>
@@ -5993,8 +5759,8 @@
         </p:blipFill>
         <p:spPr>
           <a:xfrm>
-            <a:off x="877927" y="1188720"/>
-            <a:ext cx="10451386" cy="5285232"/>
+            <a:off x="650310" y="960120"/>
+            <a:ext cx="10906621" cy="5513832"/>
           </a:xfrm>
           <a:prstGeom prst="rect">
             <a:avLst/>
@@ -6098,54 +5864,15 @@
                 <a:ea typeface="Microsoft YaHei" pitchFamily="34" charset="-122"/>
                 <a:cs typeface="Microsoft YaHei" pitchFamily="34" charset="-120"/>
               </a:rPr>
-              <a:t>问题二：皮层组织块中，MS 相对对照的改变</a:t>
+              <a:t>MS 皮层：未见同等幅度的变化</a:t>
             </a:r>
             <a:endParaRPr lang="en-US" sz="2500" dirty="0"/>
           </a:p>
         </p:txBody>
       </p:sp>
-      <p:sp>
-        <p:nvSpPr>
-          <p:cNvPr id="4" name="Text 2"/>
-          <p:cNvSpPr txBox="1"/>
-          <p:nvPr/>
-        </p:nvSpPr>
-        <p:spPr>
-          <a:xfrm>
-            <a:off x="548640" y="786384"/>
-            <a:ext cx="11064240" cy="329184"/>
-          </a:xfrm>
-          <a:prstGeom prst="rect">
-            <a:avLst/>
-          </a:prstGeom>
-          <a:noFill/>
-          <a:ln/>
-        </p:spPr>
-        <p:txBody>
-          <a:bodyPr wrap="square" lIns="0" tIns="0" rIns="0" bIns="0" rtlCol="0" anchor="ctr"/>
-          <a:lstStyle/>
-          <a:p>
-            <a:pPr indent="0" marL="0">
-              <a:buNone/>
-            </a:pPr>
-            <a:r>
-              <a:rPr lang="en-US" sz="1350" dirty="0">
-                <a:solidFill>
-                  <a:srgbClr val="6E6E6E"/>
-                </a:solidFill>
-                <a:latin typeface="Microsoft YaHei" pitchFamily="34" charset="0"/>
-                <a:ea typeface="Microsoft YaHei" pitchFamily="34" charset="-122"/>
-                <a:cs typeface="Microsoft YaHei" pitchFamily="34" charset="-120"/>
-              </a:rPr>
-              <a:t>Schirmer 队列。六类细胞的倍数变化区间全部跨 1，无一类达到白质中少突胶质的幅度。</a:t>
-            </a:r>
-            <a:endParaRPr lang="en-US" sz="1350" dirty="0"/>
-          </a:p>
-        </p:txBody>
-      </p:sp>
       <p:pic>
         <p:nvPicPr>
-          <p:cNvPr id="5" name="Image 0" descr="/home/user/aaa/results/mda5/figs/fig_q2_gm.png">    </p:cNvPr>
+          <p:cNvPr id="4" name="Image 0" descr="/home/user/aaa/results/mda5/figs/fig_q2_gm.png">    </p:cNvPr>
           <p:cNvPicPr>
             <a:picLocks noChangeAspect="1"/>
           </p:cNvPicPr>
@@ -6159,8 +5886,8 @@
         </p:blipFill>
         <p:spPr>
           <a:xfrm>
-            <a:off x="1639086" y="1188720"/>
-            <a:ext cx="8929069" cy="5285232"/>
+            <a:off x="1444400" y="960120"/>
+            <a:ext cx="9318439" cy="5513832"/>
           </a:xfrm>
           <a:prstGeom prst="rect">
             <a:avLst/>
@@ -6264,54 +5991,15 @@
                 <a:ea typeface="Microsoft YaHei" pitchFamily="34" charset="-122"/>
                 <a:cs typeface="Microsoft YaHei" pitchFamily="34" charset="-120"/>
               </a:rPr>
-              <a:t>问题二：两个区室的改变是否相同</a:t>
+              <a:t>两个区域变化幅度之差</a:t>
             </a:r>
             <a:endParaRPr lang="en-US" sz="2500" dirty="0"/>
           </a:p>
         </p:txBody>
       </p:sp>
-      <p:sp>
-        <p:nvSpPr>
-          <p:cNvPr id="4" name="Text 2"/>
-          <p:cNvSpPr txBox="1"/>
-          <p:nvPr/>
-        </p:nvSpPr>
-        <p:spPr>
-          <a:xfrm>
-            <a:off x="548640" y="786384"/>
-            <a:ext cx="11064240" cy="329184"/>
-          </a:xfrm>
-          <a:prstGeom prst="rect">
-            <a:avLst/>
-          </a:prstGeom>
-          <a:noFill/>
-          <a:ln/>
-        </p:spPr>
-        <p:txBody>
-          <a:bodyPr wrap="square" lIns="0" tIns="0" rIns="0" bIns="0" rtlCol="0" anchor="ctr"/>
-          <a:lstStyle/>
-          <a:p>
-            <a:pPr indent="0" marL="0">
-              <a:buNone/>
-            </a:pPr>
-            <a:r>
-              <a:rPr lang="en-US" sz="1350" dirty="0">
-                <a:solidFill>
-                  <a:srgbClr val="6E6E6E"/>
-                </a:solidFill>
-                <a:latin typeface="Microsoft YaHei" pitchFamily="34" charset="0"/>
-                <a:ea typeface="Microsoft YaHei" pitchFamily="34" charset="-122"/>
-                <a:cs typeface="Microsoft YaHei" pitchFamily="34" charset="-120"/>
-              </a:rPr>
-              <a:t>画的是自助 95% 区间，不是显著性星号。六类中只有两类两侧都可估计，其余因供体不足或对照中位为零而不可判定。</a:t>
-            </a:r>
-            <a:endParaRPr lang="en-US" sz="1350" dirty="0"/>
-          </a:p>
-        </p:txBody>
-      </p:sp>
       <p:pic>
         <p:nvPicPr>
-          <p:cNvPr id="5" name="Image 0" descr="/home/user/aaa/results/mda5/figs/fig_q2_interaction.png">    </p:cNvPr>
+          <p:cNvPr id="4" name="Image 0" descr="/home/user/aaa/results/mda5/figs/fig_q2_interaction.png">    </p:cNvPr>
           <p:cNvPicPr>
             <a:picLocks noChangeAspect="1"/>
           </p:cNvPicPr>
@@ -6325,8 +6013,8 @@
         </p:blipFill>
         <p:spPr>
           <a:xfrm>
-            <a:off x="411480" y="1246742"/>
-            <a:ext cx="11384280" cy="5169187"/>
+            <a:off x="411480" y="1213819"/>
+            <a:ext cx="11384280" cy="5006434"/>
           </a:xfrm>
           <a:prstGeom prst="rect">
             <a:avLst/>
@@ -6430,54 +6118,15 @@
                 <a:ea typeface="Microsoft YaHei" pitchFamily="34" charset="-122"/>
                 <a:cs typeface="Microsoft YaHei" pitchFamily="34" charset="-120"/>
               </a:rPr>
-              <a:t>为什么皮层那一侧只能说到这里</a:t>
+              <a:t>皮层标本含皮层下白质，MS 取材更深</a:t>
             </a:r>
             <a:endParaRPr lang="en-US" sz="2500" dirty="0"/>
           </a:p>
         </p:txBody>
       </p:sp>
-      <p:sp>
-        <p:nvSpPr>
-          <p:cNvPr id="4" name="Text 2"/>
-          <p:cNvSpPr txBox="1"/>
-          <p:nvPr/>
-        </p:nvSpPr>
-        <p:spPr>
-          <a:xfrm>
-            <a:off x="548640" y="786384"/>
-            <a:ext cx="11064240" cy="329184"/>
-          </a:xfrm>
-          <a:prstGeom prst="rect">
-            <a:avLst/>
-          </a:prstGeom>
-          <a:noFill/>
-          <a:ln/>
-        </p:spPr>
-        <p:txBody>
-          <a:bodyPr wrap="square" lIns="0" tIns="0" rIns="0" bIns="0" rtlCol="0" anchor="ctr"/>
-          <a:lstStyle/>
-          <a:p>
-            <a:pPr indent="0" marL="0">
-              <a:buNone/>
-            </a:pPr>
-            <a:r>
-              <a:rPr lang="en-US" sz="1350" dirty="0">
-                <a:solidFill>
-                  <a:srgbClr val="6E6E6E"/>
-                </a:solidFill>
-                <a:latin typeface="Microsoft YaHei" pitchFamily="34" charset="0"/>
-                <a:ea typeface="Microsoft YaHei" pitchFamily="34" charset="-122"/>
-                <a:cs typeface="Microsoft YaHei" pitchFamily="34" charset="-120"/>
-              </a:rPr>
-              <a:t>Schirmer 的组织块按原文方法跨越整个皮层并带有其下的皮层下白质。MS 块取得更深，白质成分显著多于对照块，故该侧的疾病对比与解剖深度混杂。</a:t>
-            </a:r>
-            <a:endParaRPr lang="en-US" sz="1350" dirty="0"/>
-          </a:p>
-        </p:txBody>
-      </p:sp>
       <p:pic>
         <p:nvPicPr>
-          <p:cNvPr id="5" name="Image 0" descr="/home/user/aaa/results/mda5/figs/fig_confound.png">    </p:cNvPr>
+          <p:cNvPr id="4" name="Image 0" descr="/home/user/aaa/results/mda5/figs/fig_confound.png">    </p:cNvPr>
           <p:cNvPicPr>
             <a:picLocks noChangeAspect="1"/>
           </p:cNvPicPr>
@@ -6491,8 +6140,8 @@
         </p:blipFill>
         <p:spPr>
           <a:xfrm>
-            <a:off x="1064298" y="1316736"/>
-            <a:ext cx="10078645" cy="5157216"/>
+            <a:off x="715834" y="960120"/>
+            <a:ext cx="10775572" cy="5513832"/>
           </a:xfrm>
           <a:prstGeom prst="rect">
             <a:avLst/>

</xml_diff>

<commit_message>
Spell out the normalization on the axes instead of writing CP10k
CP10k is counts per 10,000: each nucleus's gene counts divided by that
nucleus's total transcript count, times ten thousand. The axes now say
每万转录本中的计数 so the quantity is readable without knowing the
abbreviation, and the colour bar says 对数归一化 rather than log 归一化.

The cell-type axis ran to 1.4 while the largest value is 1.10, which invited
the question of what sat at 1.4. Nothing did; the range is trimmed. Long cell
names no longer collide on the violin panel.

Co-Authored-By: Claude Opus 5 <noreply@anthropic.com>
Claude-Session: https://claude.ai/code/session_01Puq8M8AiJGJDbdbxajvkZL
</commit_message>
<xml_diff>
--- a/results/mda5/MDA5_IFIH1_人脑与MS.pptx
+++ b/results/mda5/MDA5_IFIH1_人脑与MS.pptx
@@ -2044,8 +2044,8 @@
         </p:blipFill>
         <p:spPr>
           <a:xfrm>
-            <a:off x="411480" y="1067218"/>
-            <a:ext cx="11384280" cy="5299636"/>
+            <a:off x="411480" y="1067989"/>
+            <a:ext cx="11384280" cy="5298094"/>
           </a:xfrm>
           <a:prstGeom prst="rect">
             <a:avLst/>
@@ -5378,8 +5378,8 @@
         </p:blipFill>
         <p:spPr>
           <a:xfrm>
-            <a:off x="411480" y="1429127"/>
-            <a:ext cx="11384280" cy="4575817"/>
+            <a:off x="411480" y="1560792"/>
+            <a:ext cx="11384280" cy="4312488"/>
           </a:xfrm>
           <a:prstGeom prst="rect">
             <a:avLst/>

</xml_diff>

<commit_message>
Cut the batch-robustness, literature and limitations slides
Nine slides remain: the two questions, the cell-type distribution, the normal
compartment contrast, the disease effect in each compartment, the difference
between them, the dissection confound, and the white-matter atlas.

Add scripts/mda5/macnair_analysis.py. Macnair 2025's processed data turns out
to be public on Zenodo rather than behind EGA, and it carries cortex and
subcortical white matter through one protocol: 632,375 nuclei, 80 donors, and
at 30 nuclei per donor every major cell type is estimable in both
compartments, microglia included at 12 control and 20 MS donors in cortex.
That removes the aliasing of compartment with study that no reasoning inside a
log2 ratio could have fixed. Results are recorded in out_macnair_effects.csv
but not yet on any slide.

Co-Authored-By: Claude Opus 5 <noreply@anthropic.com>
Claude-Session: https://claude.ai/code/session_01Puq8M8AiJGJDbdbxajvkZL
</commit_message>
<xml_diff>
--- a/results/mda5/MDA5_IFIH1_人脑与MS.pptx
+++ b/results/mda5/MDA5_IFIH1_人脑与MS.pptx
@@ -14,12 +14,9 @@
     <p:sldId id="262" r:id="rId8"/>
     <p:sldId id="263" r:id="rId9"/>
     <p:sldId id="264" r:id="rId10"/>
-    <p:sldId id="265" r:id="rId11"/>
-    <p:sldId id="266" r:id="rId12"/>
-    <p:sldId id="267" r:id="rId13"/>
   </p:sldIdLst>
   <p:notesMasterIdLst>
-    <p:notesMasterId r:id="rId14"/>
+    <p:notesMasterId r:id="rId11"/>
   </p:notesMasterIdLst>
   <p:sldSz cx="12192000" cy="6858000"/>
   <p:notesSz cx="6858000" cy="12192000"/>
@@ -537,270 +534,6 @@
             <a:fld id="{F7021451-1387-4CA6-816F-3879F97B5CBC}" type="slidenum">
               <a:rPr lang="en-US"/>
               <a:t>1</a:t>
-            </a:fld>
-            <a:endParaRPr lang="en-US"/>
-          </a:p>
-        </p:txBody>
-      </p:sp>
-    </p:spTree>
-    <p:extLst>
-      <p:ext uri="{BB962C8B-B14F-4D97-AF65-F5344CB8AC3E}">
-        <p14:creationId xmlns:p14="http://schemas.microsoft.com/office/powerpoint/2010/main" val="1024086991"/>
-      </p:ext>
-    </p:extLst>
-  </p:cSld>
-  <p:clrMapOvr>
-    <a:masterClrMapping/>
-  </p:clrMapOvr>
-</p:notes>
-</file>
-
-<file path=ppt/notesSlides/notesSlide10.xml><?xml version="1.0" encoding="utf-8"?>
-<p:notes xmlns:a="http://schemas.openxmlformats.org/drawingml/2006/main" xmlns:r="http://schemas.openxmlformats.org/officeDocument/2006/relationships" xmlns:p="http://schemas.openxmlformats.org/presentationml/2006/main">
-  <p:cSld>
-    <p:spTree>
-      <p:nvGrpSpPr>
-        <p:cNvPr id="1" name=""/>
-        <p:cNvGrpSpPr/>
-        <p:nvPr/>
-      </p:nvGrpSpPr>
-      <p:grpSpPr>
-        <a:xfrm>
-          <a:off x="0" y="0"/>
-          <a:ext cx="0" cy="0"/>
-          <a:chOff x="0" y="0"/>
-          <a:chExt cx="0" cy="0"/>
-        </a:xfrm>
-      </p:grpSpPr>
-      <p:sp>
-        <p:nvSpPr>
-          <p:cNvPr id="2" name="Slide Image Placeholder 1"/>
-          <p:cNvSpPr>
-            <a:spLocks noGrp="1" noRot="1" noChangeAspect="1"/>
-          </p:cNvSpPr>
-          <p:nvPr>
-            <p:ph type="sldImg"/>
-          </p:nvPr>
-        </p:nvSpPr>
-        <p:spPr/>
-      </p:sp>
-      <p:sp>
-        <p:nvSpPr>
-          <p:cNvPr id="3" name="Notes Placeholder 2"/>
-          <p:cNvSpPr>
-            <a:spLocks noGrp="1"/>
-          </p:cNvSpPr>
-          <p:nvPr>
-            <p:ph type="body" idx="1"/>
-          </p:nvPr>
-        </p:nvSpPr>
-        <p:spPr/>
-        <p:txBody>
-          <a:bodyPr/>
-          <a:lstStyle/>
-          <a:p>
-            <a:r>
-              <a:rPr lang="en-US" dirty="0"/>
-              <a:t/>
-            </a:r>
-            <a:endParaRPr lang="en-US" dirty="0"/>
-          </a:p>
-        </p:txBody>
-      </p:sp>
-      <p:sp>
-        <p:nvSpPr>
-          <p:cNvPr id="4" name="Slide Number Placeholder 3"/>
-          <p:cNvSpPr>
-            <a:spLocks noGrp="1"/>
-          </p:cNvSpPr>
-          <p:nvPr>
-            <p:ph type="sldNum" sz="quarter" idx="10"/>
-          </p:nvPr>
-        </p:nvSpPr>
-        <p:spPr/>
-        <p:txBody>
-          <a:bodyPr/>
-          <a:lstStyle/>
-          <a:p>
-            <a:fld id="{F7021451-1387-4CA6-816F-3879F97B5CBC}" type="slidenum">
-              <a:rPr lang="en-US"/>
-              <a:t>10</a:t>
-            </a:fld>
-            <a:endParaRPr lang="en-US"/>
-          </a:p>
-        </p:txBody>
-      </p:sp>
-    </p:spTree>
-    <p:extLst>
-      <p:ext uri="{BB962C8B-B14F-4D97-AF65-F5344CB8AC3E}">
-        <p14:creationId xmlns:p14="http://schemas.microsoft.com/office/powerpoint/2010/main" val="1024086991"/>
-      </p:ext>
-    </p:extLst>
-  </p:cSld>
-  <p:clrMapOvr>
-    <a:masterClrMapping/>
-  </p:clrMapOvr>
-</p:notes>
-</file>
-
-<file path=ppt/notesSlides/notesSlide11.xml><?xml version="1.0" encoding="utf-8"?>
-<p:notes xmlns:a="http://schemas.openxmlformats.org/drawingml/2006/main" xmlns:r="http://schemas.openxmlformats.org/officeDocument/2006/relationships" xmlns:p="http://schemas.openxmlformats.org/presentationml/2006/main">
-  <p:cSld>
-    <p:spTree>
-      <p:nvGrpSpPr>
-        <p:cNvPr id="1" name=""/>
-        <p:cNvGrpSpPr/>
-        <p:nvPr/>
-      </p:nvGrpSpPr>
-      <p:grpSpPr>
-        <a:xfrm>
-          <a:off x="0" y="0"/>
-          <a:ext cx="0" cy="0"/>
-          <a:chOff x="0" y="0"/>
-          <a:chExt cx="0" cy="0"/>
-        </a:xfrm>
-      </p:grpSpPr>
-      <p:sp>
-        <p:nvSpPr>
-          <p:cNvPr id="2" name="Slide Image Placeholder 1"/>
-          <p:cNvSpPr>
-            <a:spLocks noGrp="1" noRot="1" noChangeAspect="1"/>
-          </p:cNvSpPr>
-          <p:nvPr>
-            <p:ph type="sldImg"/>
-          </p:nvPr>
-        </p:nvSpPr>
-        <p:spPr/>
-      </p:sp>
-      <p:sp>
-        <p:nvSpPr>
-          <p:cNvPr id="3" name="Notes Placeholder 2"/>
-          <p:cNvSpPr>
-            <a:spLocks noGrp="1"/>
-          </p:cNvSpPr>
-          <p:nvPr>
-            <p:ph type="body" idx="1"/>
-          </p:nvPr>
-        </p:nvSpPr>
-        <p:spPr/>
-        <p:txBody>
-          <a:bodyPr/>
-          <a:lstStyle/>
-          <a:p>
-            <a:r>
-              <a:rPr lang="en-US" dirty="0"/>
-              <a:t/>
-            </a:r>
-            <a:endParaRPr lang="en-US" dirty="0"/>
-          </a:p>
-        </p:txBody>
-      </p:sp>
-      <p:sp>
-        <p:nvSpPr>
-          <p:cNvPr id="4" name="Slide Number Placeholder 3"/>
-          <p:cNvSpPr>
-            <a:spLocks noGrp="1"/>
-          </p:cNvSpPr>
-          <p:nvPr>
-            <p:ph type="sldNum" sz="quarter" idx="10"/>
-          </p:nvPr>
-        </p:nvSpPr>
-        <p:spPr/>
-        <p:txBody>
-          <a:bodyPr/>
-          <a:lstStyle/>
-          <a:p>
-            <a:fld id="{F7021451-1387-4CA6-816F-3879F97B5CBC}" type="slidenum">
-              <a:rPr lang="en-US"/>
-              <a:t>11</a:t>
-            </a:fld>
-            <a:endParaRPr lang="en-US"/>
-          </a:p>
-        </p:txBody>
-      </p:sp>
-    </p:spTree>
-    <p:extLst>
-      <p:ext uri="{BB962C8B-B14F-4D97-AF65-F5344CB8AC3E}">
-        <p14:creationId xmlns:p14="http://schemas.microsoft.com/office/powerpoint/2010/main" val="1024086991"/>
-      </p:ext>
-    </p:extLst>
-  </p:cSld>
-  <p:clrMapOvr>
-    <a:masterClrMapping/>
-  </p:clrMapOvr>
-</p:notes>
-</file>
-
-<file path=ppt/notesSlides/notesSlide12.xml><?xml version="1.0" encoding="utf-8"?>
-<p:notes xmlns:a="http://schemas.openxmlformats.org/drawingml/2006/main" xmlns:r="http://schemas.openxmlformats.org/officeDocument/2006/relationships" xmlns:p="http://schemas.openxmlformats.org/presentationml/2006/main">
-  <p:cSld>
-    <p:spTree>
-      <p:nvGrpSpPr>
-        <p:cNvPr id="1" name=""/>
-        <p:cNvGrpSpPr/>
-        <p:nvPr/>
-      </p:nvGrpSpPr>
-      <p:grpSpPr>
-        <a:xfrm>
-          <a:off x="0" y="0"/>
-          <a:ext cx="0" cy="0"/>
-          <a:chOff x="0" y="0"/>
-          <a:chExt cx="0" cy="0"/>
-        </a:xfrm>
-      </p:grpSpPr>
-      <p:sp>
-        <p:nvSpPr>
-          <p:cNvPr id="2" name="Slide Image Placeholder 1"/>
-          <p:cNvSpPr>
-            <a:spLocks noGrp="1" noRot="1" noChangeAspect="1"/>
-          </p:cNvSpPr>
-          <p:nvPr>
-            <p:ph type="sldImg"/>
-          </p:nvPr>
-        </p:nvSpPr>
-        <p:spPr/>
-      </p:sp>
-      <p:sp>
-        <p:nvSpPr>
-          <p:cNvPr id="3" name="Notes Placeholder 2"/>
-          <p:cNvSpPr>
-            <a:spLocks noGrp="1"/>
-          </p:cNvSpPr>
-          <p:nvPr>
-            <p:ph type="body" idx="1"/>
-          </p:nvPr>
-        </p:nvSpPr>
-        <p:spPr/>
-        <p:txBody>
-          <a:bodyPr/>
-          <a:lstStyle/>
-          <a:p>
-            <a:r>
-              <a:rPr lang="en-US" dirty="0"/>
-              <a:t/>
-            </a:r>
-            <a:endParaRPr lang="en-US" dirty="0"/>
-          </a:p>
-        </p:txBody>
-      </p:sp>
-      <p:sp>
-        <p:nvSpPr>
-          <p:cNvPr id="4" name="Slide Number Placeholder 3"/>
-          <p:cNvSpPr>
-            <a:spLocks noGrp="1"/>
-          </p:cNvSpPr>
-          <p:nvPr>
-            <p:ph type="sldNum" sz="quarter" idx="10"/>
-          </p:nvPr>
-        </p:nvSpPr>
-        <p:spPr/>
-        <p:txBody>
-          <a:bodyPr/>
-          <a:lstStyle/>
-          <a:p>
-            <a:fld id="{F7021451-1387-4CA6-816F-3879F97B5CBC}" type="slidenum">
-              <a:rPr lang="en-US"/>
-              <a:t>12</a:t>
             </a:fld>
             <a:endParaRPr lang="en-US"/>
           </a:p>
@@ -1933,1704 +1666,6 @@
 </p:sld>
 </file>
 
-<file path=ppt/slides/slide10.xml><?xml version="1.0" encoding="utf-8"?>
-<p:sld xmlns:a="http://schemas.openxmlformats.org/drawingml/2006/main" xmlns:r="http://schemas.openxmlformats.org/officeDocument/2006/relationships" xmlns:p="http://schemas.openxmlformats.org/presentationml/2006/main">
-  <p:cSld name="Slide 10">
-    <p:spTree>
-      <p:nvGrpSpPr>
-        <p:cNvPr id="1" name=""/>
-        <p:cNvGrpSpPr/>
-        <p:nvPr/>
-      </p:nvGrpSpPr>
-      <p:grpSpPr>
-        <a:xfrm>
-          <a:off x="0" y="0"/>
-          <a:ext cx="0" cy="0"/>
-          <a:chOff x="0" y="0"/>
-          <a:chExt cx="0" cy="0"/>
-        </a:xfrm>
-      </p:grpSpPr>
-      <p:sp>
-        <p:nvSpPr>
-          <p:cNvPr id="2" name="Text 0"/>
-          <p:cNvSpPr txBox="1"/>
-          <p:nvPr/>
-        </p:nvSpPr>
-        <p:spPr>
-          <a:xfrm>
-            <a:off x="11430000" y="6355080"/>
-            <a:ext cx="457200" cy="274320"/>
-          </a:xfrm>
-          <a:prstGeom prst="rect">
-            <a:avLst/>
-          </a:prstGeom>
-          <a:noFill/>
-          <a:ln/>
-        </p:spPr>
-        <p:txBody>
-          <a:bodyPr wrap="square" lIns="0" tIns="0" rIns="0" bIns="0" rtlCol="0" anchor="ctr"/>
-          <a:lstStyle/>
-          <a:p>
-            <a:pPr algn="r" indent="0" marL="0">
-              <a:buNone/>
-            </a:pPr>
-            <a:r>
-              <a:rPr lang="en-US" sz="1000" dirty="0">
-                <a:solidFill>
-                  <a:srgbClr val="6E6E6E"/>
-                </a:solidFill>
-                <a:latin typeface="Calibri" pitchFamily="34" charset="0"/>
-                <a:ea typeface="Calibri" pitchFamily="34" charset="-122"/>
-                <a:cs typeface="Calibri" pitchFamily="34" charset="-120"/>
-              </a:rPr>
-              <a:t>9</a:t>
-            </a:r>
-            <a:endParaRPr lang="en-US" sz="1000" dirty="0"/>
-          </a:p>
-        </p:txBody>
-      </p:sp>
-      <p:sp>
-        <p:nvSpPr>
-          <p:cNvPr id="3" name="Text 1"/>
-          <p:cNvSpPr txBox="1"/>
-          <p:nvPr/>
-        </p:nvSpPr>
-        <p:spPr>
-          <a:xfrm>
-            <a:off x="548640" y="274320"/>
-            <a:ext cx="11064240" cy="475488"/>
-          </a:xfrm>
-          <a:prstGeom prst="rect">
-            <a:avLst/>
-          </a:prstGeom>
-          <a:noFill/>
-          <a:ln/>
-        </p:spPr>
-        <p:txBody>
-          <a:bodyPr wrap="square" lIns="0" tIns="0" rIns="0" bIns="0" rtlCol="0" anchor="ctr"/>
-          <a:lstStyle/>
-          <a:p>
-            <a:pPr indent="0" marL="0">
-              <a:buNone/>
-            </a:pPr>
-            <a:r>
-              <a:rPr lang="en-US" sz="2500" b="1" dirty="0">
-                <a:solidFill>
-                  <a:srgbClr val="000000"/>
-                </a:solidFill>
-                <a:latin typeface="Microsoft YaHei" pitchFamily="34" charset="0"/>
-                <a:ea typeface="Microsoft YaHei" pitchFamily="34" charset="-122"/>
-                <a:cs typeface="Microsoft YaHei" pitchFamily="34" charset="-120"/>
-              </a:rPr>
-              <a:t>白质单核图谱与脱髓鞘病灶分期</a:t>
-            </a:r>
-            <a:endParaRPr lang="en-US" sz="2500" dirty="0"/>
-          </a:p>
-        </p:txBody>
-      </p:sp>
-      <p:pic>
-        <p:nvPicPr>
-          <p:cNvPr id="4" name="Image 0" descr="/home/user/aaa/results/mda5/figs/fig_umap_wm.png">    </p:cNvPr>
-          <p:cNvPicPr>
-            <a:picLocks noChangeAspect="1"/>
-          </p:cNvPicPr>
-          <p:nvPr/>
-        </p:nvPicPr>
-        <p:blipFill>
-          <a:blip r:embed="rId1"/>
-          <a:stretch>
-            <a:fillRect/>
-          </a:stretch>
-        </p:blipFill>
-        <p:spPr>
-          <a:xfrm>
-            <a:off x="411480" y="1067989"/>
-            <a:ext cx="11384280" cy="5298094"/>
-          </a:xfrm>
-          <a:prstGeom prst="rect">
-            <a:avLst/>
-          </a:prstGeom>
-        </p:spPr>
-      </p:pic>
-    </p:spTree>
-  </p:cSld>
-  <p:clrMapOvr>
-    <a:masterClrMapping/>
-  </p:clrMapOvr>
-</p:sld>
-</file>
-
-<file path=ppt/slides/slide11.xml><?xml version="1.0" encoding="utf-8"?>
-<p:sld xmlns:a="http://schemas.openxmlformats.org/drawingml/2006/main" xmlns:r="http://schemas.openxmlformats.org/officeDocument/2006/relationships" xmlns:p="http://schemas.openxmlformats.org/presentationml/2006/main">
-  <p:cSld name="Slide 11">
-    <p:spTree>
-      <p:nvGrpSpPr>
-        <p:cNvPr id="1" name=""/>
-        <p:cNvGrpSpPr/>
-        <p:nvPr/>
-      </p:nvGrpSpPr>
-      <p:grpSpPr>
-        <a:xfrm>
-          <a:off x="0" y="0"/>
-          <a:ext cx="0" cy="0"/>
-          <a:chOff x="0" y="0"/>
-          <a:chExt cx="0" cy="0"/>
-        </a:xfrm>
-      </p:grpSpPr>
-      <p:sp>
-        <p:nvSpPr>
-          <p:cNvPr id="2" name="Text 0"/>
-          <p:cNvSpPr txBox="1"/>
-          <p:nvPr/>
-        </p:nvSpPr>
-        <p:spPr>
-          <a:xfrm>
-            <a:off x="11430000" y="6355080"/>
-            <a:ext cx="457200" cy="274320"/>
-          </a:xfrm>
-          <a:prstGeom prst="rect">
-            <a:avLst/>
-          </a:prstGeom>
-          <a:noFill/>
-          <a:ln/>
-        </p:spPr>
-        <p:txBody>
-          <a:bodyPr wrap="square" lIns="0" tIns="0" rIns="0" bIns="0" rtlCol="0" anchor="ctr"/>
-          <a:lstStyle/>
-          <a:p>
-            <a:pPr algn="r" indent="0" marL="0">
-              <a:buNone/>
-            </a:pPr>
-            <a:r>
-              <a:rPr lang="en-US" sz="1000" dirty="0">
-                <a:solidFill>
-                  <a:srgbClr val="6E6E6E"/>
-                </a:solidFill>
-                <a:latin typeface="Calibri" pitchFamily="34" charset="0"/>
-                <a:ea typeface="Calibri" pitchFamily="34" charset="-122"/>
-                <a:cs typeface="Calibri" pitchFamily="34" charset="-120"/>
-              </a:rPr>
-              <a:t>10</a:t>
-            </a:r>
-            <a:endParaRPr lang="en-US" sz="1000" dirty="0"/>
-          </a:p>
-        </p:txBody>
-      </p:sp>
-      <p:sp>
-        <p:nvSpPr>
-          <p:cNvPr id="3" name="Text 1"/>
-          <p:cNvSpPr txBox="1"/>
-          <p:nvPr/>
-        </p:nvSpPr>
-        <p:spPr>
-          <a:xfrm>
-            <a:off x="548640" y="274320"/>
-            <a:ext cx="11064240" cy="475488"/>
-          </a:xfrm>
-          <a:prstGeom prst="rect">
-            <a:avLst/>
-          </a:prstGeom>
-          <a:noFill/>
-          <a:ln/>
-        </p:spPr>
-        <p:txBody>
-          <a:bodyPr wrap="square" lIns="0" tIns="0" rIns="0" bIns="0" rtlCol="0" anchor="ctr"/>
-          <a:lstStyle/>
-          <a:p>
-            <a:pPr indent="0" marL="0">
-              <a:buNone/>
-            </a:pPr>
-            <a:r>
-              <a:rPr lang="en-US" sz="2500" b="1" dirty="0">
-                <a:solidFill>
-                  <a:srgbClr val="000000"/>
-                </a:solidFill>
-                <a:latin typeface="Microsoft YaHei" pitchFamily="34" charset="0"/>
-                <a:ea typeface="Microsoft YaHei" pitchFamily="34" charset="-122"/>
-                <a:cs typeface="Microsoft YaHei" pitchFamily="34" charset="-120"/>
-              </a:rPr>
-              <a:t>与已发表结果的关系</a:t>
-            </a:r>
-            <a:endParaRPr lang="en-US" sz="2500" dirty="0"/>
-          </a:p>
-        </p:txBody>
-      </p:sp>
-      <p:graphicFrame>
-        <p:nvGraphicFramePr>
-          <p:cNvPr id="12" name="Table 0"/>
-          <p:cNvGraphicFramePr>
-            <a:graphicFrameLocks noGrp="1"/>
-          </p:cNvGraphicFramePr>
-          <p:nvPr>
-            <p:extLst>
-              <p:ext uri="{D42A27DB-BD31-4B8C-83A1-F6EECF244321}">
-                <p14:modId xmlns:p14="http://schemas.microsoft.com/office/powerpoint/2010/main" val="1579011935"/>
-              </p:ext>
-            </p:extLst>
-          </p:nvPr>
-        </p:nvGraphicFramePr>
-        <p:xfrm>
-          <a:off x="548640" y="960120"/>
-          <a:ext cx="11064240" cy="914400"/>
-        </p:xfrm>
-        <a:graphic>
-          <a:graphicData uri="http://schemas.openxmlformats.org/drawingml/2006/table">
-            <a:tbl>
-              <a:tblPr/>
-              <a:tblGrid>
-                <a:gridCol w="3108960"/>
-                <a:gridCol w="7955280"/>
-              </a:tblGrid>
-              <a:tr h="658368">
-                <a:tc>
-                  <a:txBody>
-                    <a:bodyPr/>
-                    <a:lstStyle/>
-                    <a:p>
-                      <a:pPr indent="0" marL="0">
-                        <a:buNone/>
-                      </a:pPr>
-                      <a:r>
-                        <a:rPr lang="en-US" sz="1250" b="1" dirty="0">
-                          <a:solidFill>
-                            <a:srgbClr val="000000"/>
-                          </a:solidFill>
-                          <a:latin typeface="Microsoft YaHei" pitchFamily="34" charset="0"/>
-                          <a:ea typeface="Microsoft YaHei" pitchFamily="34" charset="-122"/>
-                          <a:cs typeface="Microsoft YaHei" pitchFamily="34" charset="-120"/>
-                        </a:rPr>
-                        <a:t>本研究结果</a:t>
-                      </a:r>
-                      <a:endParaRPr lang="en-US" sz="1250" dirty="0">
-                        <a:latin typeface="Microsoft YaHei" charset="0"/>
-                        <a:ea typeface="Microsoft YaHei" charset="0"/>
-                        <a:cs typeface="Microsoft YaHei" charset="0"/>
-                      </a:endParaRPr>
-                    </a:p>
-                  </a:txBody>
-                  <a:tcPr marL="91440" marR="91440" marT="45720" marB="45720" anchor="ctr">
-                    <a:lnL w="0" cap="flat" cmpd="sng" algn="ctr">
-                      <a:noFill/>
-                    </a:lnL>
-                    <a:lnR w="0" cap="flat" cmpd="sng" algn="ctr">
-                      <a:noFill/>
-                    </a:lnR>
-                    <a:lnT w="0" cap="flat" cmpd="sng" algn="ctr">
-                      <a:noFill/>
-                    </a:lnT>
-                    <a:lnB w="12700" cap="flat" cmpd="sng" algn="ctr">
-                      <a:solidFill>
-                        <a:srgbClr val="C8CCD2"/>
-                      </a:solidFill>
-                      <a:prstDash val="solid"/>
-                      <a:round/>
-                      <a:headEnd type="none" w="med" len="med"/>
-                      <a:tailEnd type="none" w="med" len="med"/>
-                    </a:lnB>
-                  </a:tcPr>
-                </a:tc>
-                <a:tc>
-                  <a:txBody>
-                    <a:bodyPr/>
-                    <a:lstStyle/>
-                    <a:p>
-                      <a:pPr indent="0" marL="0">
-                        <a:buNone/>
-                      </a:pPr>
-                      <a:r>
-                        <a:rPr lang="en-US" sz="1250" b="1" dirty="0">
-                          <a:solidFill>
-                            <a:srgbClr val="000000"/>
-                          </a:solidFill>
-                          <a:latin typeface="Microsoft YaHei" pitchFamily="34" charset="0"/>
-                          <a:ea typeface="Microsoft YaHei" pitchFamily="34" charset="-122"/>
-                          <a:cs typeface="Microsoft YaHei" pitchFamily="34" charset="-120"/>
-                        </a:rPr>
-                        <a:t>文献状态</a:t>
-                      </a:r>
-                      <a:endParaRPr lang="en-US" sz="1250" dirty="0">
-                        <a:latin typeface="Microsoft YaHei" charset="0"/>
-                        <a:ea typeface="Microsoft YaHei" charset="0"/>
-                        <a:cs typeface="Microsoft YaHei" charset="0"/>
-                      </a:endParaRPr>
-                    </a:p>
-                  </a:txBody>
-                  <a:tcPr marL="91440" marR="91440" marT="45720" marB="45720" anchor="ctr">
-                    <a:lnL w="0" cap="flat" cmpd="sng" algn="ctr">
-                      <a:noFill/>
-                    </a:lnL>
-                    <a:lnR w="0" cap="flat" cmpd="sng" algn="ctr">
-                      <a:noFill/>
-                    </a:lnR>
-                    <a:lnT w="0" cap="flat" cmpd="sng" algn="ctr">
-                      <a:noFill/>
-                    </a:lnT>
-                    <a:lnB w="12700" cap="flat" cmpd="sng" algn="ctr">
-                      <a:solidFill>
-                        <a:srgbClr val="C8CCD2"/>
-                      </a:solidFill>
-                      <a:prstDash val="solid"/>
-                      <a:round/>
-                      <a:headEnd type="none" w="med" len="med"/>
-                      <a:tailEnd type="none" w="med" len="med"/>
-                    </a:lnB>
-                  </a:tcPr>
-                </a:tc>
-              </a:tr>
-              <a:tr h="658368">
-                <a:tc>
-                  <a:txBody>
-                    <a:bodyPr/>
-                    <a:lstStyle/>
-                    <a:p>
-                      <a:pPr indent="0" marL="0">
-                        <a:buNone/>
-                      </a:pPr>
-                      <a:r>
-                        <a:rPr lang="en-US" sz="1250" dirty="0">
-                          <a:solidFill>
-                            <a:srgbClr val="000000"/>
-                          </a:solidFill>
-                          <a:latin typeface="Microsoft YaHei" pitchFamily="34" charset="0"/>
-                          <a:ea typeface="Microsoft YaHei" pitchFamily="34" charset="-122"/>
-                          <a:cs typeface="Microsoft YaHei" pitchFamily="34" charset="-120"/>
-                        </a:rPr>
-                        <a:t>少突胶质在白质病灶上调</a:t>
-                      </a:r>
-                      <a:endParaRPr lang="en-US" sz="1250" dirty="0">
-                        <a:latin typeface="Microsoft YaHei" charset="0"/>
-                        <a:ea typeface="Microsoft YaHei" charset="0"/>
-                        <a:cs typeface="Microsoft YaHei" charset="0"/>
-                      </a:endParaRPr>
-                    </a:p>
-                  </a:txBody>
-                  <a:tcPr marL="91440" marR="91440" marT="45720" marB="45720" anchor="ctr">
-                    <a:lnL w="0" cap="flat" cmpd="sng" algn="ctr">
-                      <a:noFill/>
-                    </a:lnL>
-                    <a:lnR w="0" cap="flat" cmpd="sng" algn="ctr">
-                      <a:noFill/>
-                    </a:lnR>
-                    <a:lnT w="0" cap="flat" cmpd="sng" algn="ctr">
-                      <a:noFill/>
-                    </a:lnT>
-                    <a:lnB w="12700" cap="flat" cmpd="sng" algn="ctr">
-                      <a:solidFill>
-                        <a:srgbClr val="C8CCD2"/>
-                      </a:solidFill>
-                      <a:prstDash val="solid"/>
-                      <a:round/>
-                      <a:headEnd type="none" w="med" len="med"/>
-                      <a:tailEnd type="none" w="med" len="med"/>
-                    </a:lnB>
-                  </a:tcPr>
-                </a:tc>
-                <a:tc>
-                  <a:txBody>
-                    <a:bodyPr/>
-                    <a:lstStyle/>
-                    <a:p>
-                      <a:pPr indent="0" marL="0">
-                        <a:buNone/>
-                      </a:pPr>
-                      <a:r>
-                        <a:rPr lang="en-US" sz="1250" dirty="0">
-                          <a:solidFill>
-                            <a:srgbClr val="000000"/>
-                          </a:solidFill>
-                          <a:latin typeface="Microsoft YaHei" pitchFamily="34" charset="0"/>
-                          <a:ea typeface="Microsoft YaHei" pitchFamily="34" charset="-122"/>
-                          <a:cs typeface="Microsoft YaHei" pitchFamily="34" charset="-120"/>
-                        </a:rPr>
-                        <a:t>Lerma-Martin 2024 补充表 6 已报道：CA log2FC +0.905（padj 0.012），CI +1.095（padj 0.005）</a:t>
-                      </a:r>
-                      <a:endParaRPr lang="en-US" sz="1250" dirty="0">
-                        <a:latin typeface="Microsoft YaHei" charset="0"/>
-                        <a:ea typeface="Microsoft YaHei" charset="0"/>
-                        <a:cs typeface="Microsoft YaHei" charset="0"/>
-                      </a:endParaRPr>
-                    </a:p>
-                  </a:txBody>
-                  <a:tcPr marL="91440" marR="91440" marT="45720" marB="45720" anchor="ctr">
-                    <a:lnL w="0" cap="flat" cmpd="sng" algn="ctr">
-                      <a:noFill/>
-                    </a:lnL>
-                    <a:lnR w="0" cap="flat" cmpd="sng" algn="ctr">
-                      <a:noFill/>
-                    </a:lnR>
-                    <a:lnT w="0" cap="flat" cmpd="sng" algn="ctr">
-                      <a:noFill/>
-                    </a:lnT>
-                    <a:lnB w="12700" cap="flat" cmpd="sng" algn="ctr">
-                      <a:solidFill>
-                        <a:srgbClr val="C8CCD2"/>
-                      </a:solidFill>
-                      <a:prstDash val="solid"/>
-                      <a:round/>
-                      <a:headEnd type="none" w="med" len="med"/>
-                      <a:tailEnd type="none" w="med" len="med"/>
-                    </a:lnB>
-                  </a:tcPr>
-                </a:tc>
-              </a:tr>
-              <a:tr h="658368">
-                <a:tc>
-                  <a:txBody>
-                    <a:bodyPr/>
-                    <a:lstStyle/>
-                    <a:p>
-                      <a:pPr indent="0" marL="0">
-                        <a:buNone/>
-                      </a:pPr>
-                      <a:r>
-                        <a:rPr lang="en-US" sz="1250" dirty="0">
-                          <a:solidFill>
-                            <a:srgbClr val="000000"/>
-                          </a:solidFill>
-                          <a:latin typeface="Microsoft YaHei" pitchFamily="34" charset="0"/>
-                          <a:ea typeface="Microsoft YaHei" pitchFamily="34" charset="-122"/>
-                          <a:cs typeface="Microsoft YaHei" pitchFamily="34" charset="-120"/>
-                        </a:rPr>
-                        <a:t>同一队列髓系未达显著</a:t>
-                      </a:r>
-                      <a:endParaRPr lang="en-US" sz="1250" dirty="0">
-                        <a:latin typeface="Microsoft YaHei" charset="0"/>
-                        <a:ea typeface="Microsoft YaHei" charset="0"/>
-                        <a:cs typeface="Microsoft YaHei" charset="0"/>
-                      </a:endParaRPr>
-                    </a:p>
-                  </a:txBody>
-                  <a:tcPr marL="91440" marR="91440" marT="45720" marB="45720" anchor="ctr">
-                    <a:lnL w="0" cap="flat" cmpd="sng" algn="ctr">
-                      <a:noFill/>
-                    </a:lnL>
-                    <a:lnR w="0" cap="flat" cmpd="sng" algn="ctr">
-                      <a:noFill/>
-                    </a:lnR>
-                    <a:lnT w="0" cap="flat" cmpd="sng" algn="ctr">
-                      <a:noFill/>
-                    </a:lnT>
-                    <a:lnB w="12700" cap="flat" cmpd="sng" algn="ctr">
-                      <a:solidFill>
-                        <a:srgbClr val="C8CCD2"/>
-                      </a:solidFill>
-                      <a:prstDash val="solid"/>
-                      <a:round/>
-                      <a:headEnd type="none" w="med" len="med"/>
-                      <a:tailEnd type="none" w="med" len="med"/>
-                    </a:lnB>
-                  </a:tcPr>
-                </a:tc>
-                <a:tc>
-                  <a:txBody>
-                    <a:bodyPr/>
-                    <a:lstStyle/>
-                    <a:p>
-                      <a:pPr indent="0" marL="0">
-                        <a:buNone/>
-                      </a:pPr>
-                      <a:r>
-                        <a:rPr lang="en-US" sz="1250" dirty="0">
-                          <a:solidFill>
-                            <a:srgbClr val="000000"/>
-                          </a:solidFill>
-                          <a:latin typeface="Microsoft YaHei" pitchFamily="34" charset="0"/>
-                          <a:ea typeface="Microsoft YaHei" pitchFamily="34" charset="-122"/>
-                          <a:cs typeface="Microsoft YaHei" pitchFamily="34" charset="-120"/>
-                        </a:rPr>
-                        <a:t>与原作者一致，其补充表髓系 padj = 0.116</a:t>
-                      </a:r>
-                      <a:endParaRPr lang="en-US" sz="1250" dirty="0">
-                        <a:latin typeface="Microsoft YaHei" charset="0"/>
-                        <a:ea typeface="Microsoft YaHei" charset="0"/>
-                        <a:cs typeface="Microsoft YaHei" charset="0"/>
-                      </a:endParaRPr>
-                    </a:p>
-                  </a:txBody>
-                  <a:tcPr marL="91440" marR="91440" marT="45720" marB="45720" anchor="ctr">
-                    <a:lnL w="0" cap="flat" cmpd="sng" algn="ctr">
-                      <a:noFill/>
-                    </a:lnL>
-                    <a:lnR w="0" cap="flat" cmpd="sng" algn="ctr">
-                      <a:noFill/>
-                    </a:lnR>
-                    <a:lnT w="0" cap="flat" cmpd="sng" algn="ctr">
-                      <a:noFill/>
-                    </a:lnT>
-                    <a:lnB w="12700" cap="flat" cmpd="sng" algn="ctr">
-                      <a:solidFill>
-                        <a:srgbClr val="C8CCD2"/>
-                      </a:solidFill>
-                      <a:prstDash val="solid"/>
-                      <a:round/>
-                      <a:headEnd type="none" w="med" len="med"/>
-                      <a:tailEnd type="none" w="med" len="med"/>
-                    </a:lnB>
-                  </a:tcPr>
-                </a:tc>
-              </a:tr>
-              <a:tr h="658368">
-                <a:tc>
-                  <a:txBody>
-                    <a:bodyPr/>
-                    <a:lstStyle/>
-                    <a:p>
-                      <a:pPr indent="0" marL="0">
-                        <a:buNone/>
-                      </a:pPr>
-                      <a:r>
-                        <a:rPr lang="en-US" sz="1250" dirty="0">
-                          <a:solidFill>
-                            <a:srgbClr val="000000"/>
-                          </a:solidFill>
-                          <a:latin typeface="Microsoft YaHei" pitchFamily="34" charset="0"/>
-                          <a:ea typeface="Microsoft YaHei" pitchFamily="34" charset="-122"/>
-                          <a:cs typeface="Microsoft YaHei" pitchFamily="34" charset="-120"/>
-                        </a:rPr>
-                        <a:t>bulk 白质病灶同向上调</a:t>
-                      </a:r>
-                      <a:endParaRPr lang="en-US" sz="1250" dirty="0">
-                        <a:latin typeface="Microsoft YaHei" charset="0"/>
-                        <a:ea typeface="Microsoft YaHei" charset="0"/>
-                        <a:cs typeface="Microsoft YaHei" charset="0"/>
-                      </a:endParaRPr>
-                    </a:p>
-                  </a:txBody>
-                  <a:tcPr marL="91440" marR="91440" marT="45720" marB="45720" anchor="ctr">
-                    <a:lnL w="0" cap="flat" cmpd="sng" algn="ctr">
-                      <a:noFill/>
-                    </a:lnL>
-                    <a:lnR w="0" cap="flat" cmpd="sng" algn="ctr">
-                      <a:noFill/>
-                    </a:lnR>
-                    <a:lnT w="0" cap="flat" cmpd="sng" algn="ctr">
-                      <a:noFill/>
-                    </a:lnT>
-                    <a:lnB w="12700" cap="flat" cmpd="sng" algn="ctr">
-                      <a:solidFill>
-                        <a:srgbClr val="C8CCD2"/>
-                      </a:solidFill>
-                      <a:prstDash val="solid"/>
-                      <a:round/>
-                      <a:headEnd type="none" w="med" len="med"/>
-                      <a:tailEnd type="none" w="med" len="med"/>
-                    </a:lnB>
-                  </a:tcPr>
-                </a:tc>
-                <a:tc>
-                  <a:txBody>
-                    <a:bodyPr/>
-                    <a:lstStyle/>
-                    <a:p>
-                      <a:pPr indent="0" marL="0">
-                        <a:buNone/>
-                      </a:pPr>
-                      <a:r>
-                        <a:rPr lang="en-US" sz="1250" dirty="0">
-                          <a:solidFill>
-                            <a:srgbClr val="000000"/>
-                          </a:solidFill>
-                          <a:latin typeface="Microsoft YaHei" pitchFamily="34" charset="0"/>
-                          <a:ea typeface="Microsoft YaHei" pitchFamily="34" charset="-122"/>
-                          <a:cs typeface="Microsoft YaHei" pitchFamily="34" charset="-120"/>
-                        </a:rPr>
-                        <a:t>GSE138614 活动病灶 FDR 0.021、慢性活动 FDR 0.007；GSE283092 泡沫样活动病灶 1.79 倍</a:t>
-                      </a:r>
-                      <a:endParaRPr lang="en-US" sz="1250" dirty="0">
-                        <a:latin typeface="Microsoft YaHei" charset="0"/>
-                        <a:ea typeface="Microsoft YaHei" charset="0"/>
-                        <a:cs typeface="Microsoft YaHei" charset="0"/>
-                      </a:endParaRPr>
-                    </a:p>
-                  </a:txBody>
-                  <a:tcPr marL="91440" marR="91440" marT="45720" marB="45720" anchor="ctr">
-                    <a:lnL w="0" cap="flat" cmpd="sng" algn="ctr">
-                      <a:noFill/>
-                    </a:lnL>
-                    <a:lnR w="0" cap="flat" cmpd="sng" algn="ctr">
-                      <a:noFill/>
-                    </a:lnR>
-                    <a:lnT w="0" cap="flat" cmpd="sng" algn="ctr">
-                      <a:noFill/>
-                    </a:lnT>
-                    <a:lnB w="12700" cap="flat" cmpd="sng" algn="ctr">
-                      <a:solidFill>
-                        <a:srgbClr val="C8CCD2"/>
-                      </a:solidFill>
-                      <a:prstDash val="solid"/>
-                      <a:round/>
-                      <a:headEnd type="none" w="med" len="med"/>
-                      <a:tailEnd type="none" w="med" len="med"/>
-                    </a:lnB>
-                  </a:tcPr>
-                </a:tc>
-              </a:tr>
-              <a:tr h="658368">
-                <a:tc>
-                  <a:txBody>
-                    <a:bodyPr/>
-                    <a:lstStyle/>
-                    <a:p>
-                      <a:pPr indent="0" marL="0">
-                        <a:buNone/>
-                      </a:pPr>
-                      <a:r>
-                        <a:rPr lang="en-US" sz="1250" dirty="0">
-                          <a:solidFill>
-                            <a:srgbClr val="000000"/>
-                          </a:solidFill>
-                          <a:latin typeface="Microsoft YaHei" pitchFamily="34" charset="0"/>
-                          <a:ea typeface="Microsoft YaHei" pitchFamily="34" charset="-122"/>
-                          <a:cs typeface="Microsoft YaHei" pitchFamily="34" charset="-120"/>
-                        </a:rPr>
-                        <a:t>皮层组织块的 IFIH1</a:t>
-                      </a:r>
-                      <a:endParaRPr lang="en-US" sz="1250" dirty="0">
-                        <a:latin typeface="Microsoft YaHei" charset="0"/>
-                        <a:ea typeface="Microsoft YaHei" charset="0"/>
-                        <a:cs typeface="Microsoft YaHei" charset="0"/>
-                      </a:endParaRPr>
-                    </a:p>
-                  </a:txBody>
-                  <a:tcPr marL="91440" marR="91440" marT="45720" marB="45720" anchor="ctr">
-                    <a:lnL w="0" cap="flat" cmpd="sng" algn="ctr">
-                      <a:noFill/>
-                    </a:lnL>
-                    <a:lnR w="0" cap="flat" cmpd="sng" algn="ctr">
-                      <a:noFill/>
-                    </a:lnR>
-                    <a:lnT w="0" cap="flat" cmpd="sng" algn="ctr">
-                      <a:noFill/>
-                    </a:lnT>
-                    <a:lnB w="12700" cap="flat" cmpd="sng" algn="ctr">
-                      <a:solidFill>
-                        <a:srgbClr val="C8CCD2"/>
-                      </a:solidFill>
-                      <a:prstDash val="solid"/>
-                      <a:round/>
-                      <a:headEnd type="none" w="med" len="med"/>
-                      <a:tailEnd type="none" w="med" len="med"/>
-                    </a:lnB>
-                  </a:tcPr>
-                </a:tc>
-                <a:tc>
-                  <a:txBody>
-                    <a:bodyPr/>
-                    <a:lstStyle/>
-                    <a:p>
-                      <a:pPr indent="0" marL="0">
-                        <a:buNone/>
-                      </a:pPr>
-                      <a:r>
-                        <a:rPr lang="en-US" sz="1250" dirty="0">
-                          <a:solidFill>
-                            <a:srgbClr val="000000"/>
-                          </a:solidFill>
-                          <a:latin typeface="Microsoft YaHei" pitchFamily="34" charset="0"/>
-                          <a:ea typeface="Microsoft YaHei" pitchFamily="34" charset="-122"/>
-                          <a:cs typeface="Microsoft YaHei" pitchFamily="34" charset="-120"/>
-                        </a:rPr>
-                        <a:t>Schirmer 2019 补充表中 IFIH1 低于其检出阈值，本次为原创测量</a:t>
-                      </a:r>
-                      <a:endParaRPr lang="en-US" sz="1250" dirty="0">
-                        <a:latin typeface="Microsoft YaHei" charset="0"/>
-                        <a:ea typeface="Microsoft YaHei" charset="0"/>
-                        <a:cs typeface="Microsoft YaHei" charset="0"/>
-                      </a:endParaRPr>
-                    </a:p>
-                  </a:txBody>
-                  <a:tcPr marL="91440" marR="91440" marT="45720" marB="45720" anchor="ctr">
-                    <a:lnL w="0" cap="flat" cmpd="sng" algn="ctr">
-                      <a:noFill/>
-                    </a:lnL>
-                    <a:lnR w="0" cap="flat" cmpd="sng" algn="ctr">
-                      <a:noFill/>
-                    </a:lnR>
-                    <a:lnT w="0" cap="flat" cmpd="sng" algn="ctr">
-                      <a:noFill/>
-                    </a:lnT>
-                    <a:lnB w="12700" cap="flat" cmpd="sng" algn="ctr">
-                      <a:solidFill>
-                        <a:srgbClr val="C8CCD2"/>
-                      </a:solidFill>
-                      <a:prstDash val="solid"/>
-                      <a:round/>
-                      <a:headEnd type="none" w="med" len="med"/>
-                      <a:tailEnd type="none" w="med" len="med"/>
-                    </a:lnB>
-                  </a:tcPr>
-                </a:tc>
-              </a:tr>
-              <a:tr h="658368">
-                <a:tc>
-                  <a:txBody>
-                    <a:bodyPr/>
-                    <a:lstStyle/>
-                    <a:p>
-                      <a:pPr indent="0" marL="0">
-                        <a:buNone/>
-                      </a:pPr>
-                      <a:r>
-                        <a:rPr lang="en-US" sz="1250" dirty="0">
-                          <a:solidFill>
-                            <a:srgbClr val="000000"/>
-                          </a:solidFill>
-                          <a:latin typeface="Microsoft YaHei" pitchFamily="34" charset="0"/>
-                          <a:ea typeface="Microsoft YaHei" pitchFamily="34" charset="-122"/>
-                          <a:cs typeface="Microsoft YaHei" pitchFamily="34" charset="-120"/>
-                        </a:rPr>
-                        <a:t>GSE180759 中的 IFIH1</a:t>
-                      </a:r>
-                      <a:endParaRPr lang="en-US" sz="1250" dirty="0">
-                        <a:latin typeface="Microsoft YaHei" charset="0"/>
-                        <a:ea typeface="Microsoft YaHei" charset="0"/>
-                        <a:cs typeface="Microsoft YaHei" charset="0"/>
-                      </a:endParaRPr>
-                    </a:p>
-                  </a:txBody>
-                  <a:tcPr marL="91440" marR="91440" marT="45720" marB="45720" anchor="ctr">
-                    <a:lnL w="0" cap="flat" cmpd="sng" algn="ctr">
-                      <a:noFill/>
-                    </a:lnL>
-                    <a:lnR w="0" cap="flat" cmpd="sng" algn="ctr">
-                      <a:noFill/>
-                    </a:lnR>
-                    <a:lnT w="0" cap="flat" cmpd="sng" algn="ctr">
-                      <a:noFill/>
-                    </a:lnT>
-                    <a:lnB w="12700" cap="flat" cmpd="sng" algn="ctr">
-                      <a:solidFill>
-                        <a:srgbClr val="C8CCD2"/>
-                      </a:solidFill>
-                      <a:prstDash val="solid"/>
-                      <a:round/>
-                      <a:headEnd type="none" w="med" len="med"/>
-                      <a:tailEnd type="none" w="med" len="med"/>
-                    </a:lnB>
-                  </a:tcPr>
-                </a:tc>
-                <a:tc>
-                  <a:txBody>
-                    <a:bodyPr/>
-                    <a:lstStyle/>
-                    <a:p>
-                      <a:pPr indent="0" marL="0">
-                        <a:buNone/>
-                      </a:pPr>
-                      <a:r>
-                        <a:rPr lang="en-US" sz="1250" dirty="0">
-                          <a:solidFill>
-                            <a:srgbClr val="000000"/>
-                          </a:solidFill>
-                          <a:latin typeface="Microsoft YaHei" pitchFamily="34" charset="0"/>
-                          <a:ea typeface="Microsoft YaHei" pitchFamily="34" charset="-122"/>
-                          <a:cs typeface="Microsoft YaHei" pitchFamily="34" charset="-120"/>
-                        </a:rPr>
-                        <a:t>原文 13 个补充表中未出现</a:t>
-                      </a:r>
-                      <a:endParaRPr lang="en-US" sz="1250" dirty="0">
-                        <a:latin typeface="Microsoft YaHei" charset="0"/>
-                        <a:ea typeface="Microsoft YaHei" charset="0"/>
-                        <a:cs typeface="Microsoft YaHei" charset="0"/>
-                      </a:endParaRPr>
-                    </a:p>
-                  </a:txBody>
-                  <a:tcPr marL="91440" marR="91440" marT="45720" marB="45720" anchor="ctr">
-                    <a:lnL w="0" cap="flat" cmpd="sng" algn="ctr">
-                      <a:noFill/>
-                    </a:lnL>
-                    <a:lnR w="0" cap="flat" cmpd="sng" algn="ctr">
-                      <a:noFill/>
-                    </a:lnR>
-                    <a:lnT w="0" cap="flat" cmpd="sng" algn="ctr">
-                      <a:noFill/>
-                    </a:lnT>
-                    <a:lnB w="12700" cap="flat" cmpd="sng" algn="ctr">
-                      <a:solidFill>
-                        <a:srgbClr val="C8CCD2"/>
-                      </a:solidFill>
-                      <a:prstDash val="solid"/>
-                      <a:round/>
-                      <a:headEnd type="none" w="med" len="med"/>
-                      <a:tailEnd type="none" w="med" len="med"/>
-                    </a:lnB>
-                  </a:tcPr>
-                </a:tc>
-              </a:tr>
-              <a:tr h="658368">
-                <a:tc>
-                  <a:txBody>
-                    <a:bodyPr/>
-                    <a:lstStyle/>
-                    <a:p>
-                      <a:pPr indent="0" marL="0">
-                        <a:buNone/>
-                      </a:pPr>
-                      <a:r>
-                        <a:rPr lang="en-US" sz="1250" dirty="0">
-                          <a:solidFill>
-                            <a:srgbClr val="000000"/>
-                          </a:solidFill>
-                          <a:latin typeface="Microsoft YaHei" pitchFamily="34" charset="0"/>
-                          <a:ea typeface="Microsoft YaHei" pitchFamily="34" charset="-122"/>
-                          <a:cs typeface="Microsoft YaHei" pitchFamily="34" charset="-120"/>
-                        </a:rPr>
-                        <a:t>两个区室改变的直接对比</a:t>
-                      </a:r>
-                      <a:endParaRPr lang="en-US" sz="1250" dirty="0">
-                        <a:latin typeface="Microsoft YaHei" charset="0"/>
-                        <a:ea typeface="Microsoft YaHei" charset="0"/>
-                        <a:cs typeface="Microsoft YaHei" charset="0"/>
-                      </a:endParaRPr>
-                    </a:p>
-                  </a:txBody>
-                  <a:tcPr marL="91440" marR="91440" marT="45720" marB="45720" anchor="ctr">
-                    <a:lnL w="0" cap="flat" cmpd="sng" algn="ctr">
-                      <a:noFill/>
-                    </a:lnL>
-                    <a:lnR w="0" cap="flat" cmpd="sng" algn="ctr">
-                      <a:noFill/>
-                    </a:lnR>
-                    <a:lnT w="0" cap="flat" cmpd="sng" algn="ctr">
-                      <a:noFill/>
-                    </a:lnT>
-                    <a:lnB w="12700" cap="flat" cmpd="sng" algn="ctr">
-                      <a:solidFill>
-                        <a:srgbClr val="C8CCD2"/>
-                      </a:solidFill>
-                      <a:prstDash val="solid"/>
-                      <a:round/>
-                      <a:headEnd type="none" w="med" len="med"/>
-                      <a:tailEnd type="none" w="med" len="med"/>
-                    </a:lnB>
-                  </a:tcPr>
-                </a:tc>
-                <a:tc>
-                  <a:txBody>
-                    <a:bodyPr/>
-                    <a:lstStyle/>
-                    <a:p>
-                      <a:pPr indent="0" marL="0">
-                        <a:buNone/>
-                      </a:pPr>
-                      <a:r>
-                        <a:rPr lang="en-US" sz="1250" dirty="0">
-                          <a:solidFill>
-                            <a:srgbClr val="000000"/>
-                          </a:solidFill>
-                          <a:latin typeface="Microsoft YaHei" pitchFamily="34" charset="0"/>
-                          <a:ea typeface="Microsoft YaHei" pitchFamily="34" charset="-122"/>
-                          <a:cs typeface="Microsoft YaHei" pitchFamily="34" charset="-120"/>
-                        </a:rPr>
-                        <a:t>未见任何已发表研究做过</a:t>
-                      </a:r>
-                      <a:endParaRPr lang="en-US" sz="1250" dirty="0">
-                        <a:latin typeface="Microsoft YaHei" charset="0"/>
-                        <a:ea typeface="Microsoft YaHei" charset="0"/>
-                        <a:cs typeface="Microsoft YaHei" charset="0"/>
-                      </a:endParaRPr>
-                    </a:p>
-                  </a:txBody>
-                  <a:tcPr marL="91440" marR="91440" marT="45720" marB="45720" anchor="ctr">
-                    <a:lnL w="0" cap="flat" cmpd="sng" algn="ctr">
-                      <a:noFill/>
-                    </a:lnL>
-                    <a:lnR w="0" cap="flat" cmpd="sng" algn="ctr">
-                      <a:noFill/>
-                    </a:lnR>
-                    <a:lnT w="0" cap="flat" cmpd="sng" algn="ctr">
-                      <a:noFill/>
-                    </a:lnT>
-                    <a:lnB w="12700" cap="flat" cmpd="sng" algn="ctr">
-                      <a:solidFill>
-                        <a:srgbClr val="C8CCD2"/>
-                      </a:solidFill>
-                      <a:prstDash val="solid"/>
-                      <a:round/>
-                      <a:headEnd type="none" w="med" len="med"/>
-                      <a:tailEnd type="none" w="med" len="med"/>
-                    </a:lnB>
-                  </a:tcPr>
-                </a:tc>
-              </a:tr>
-              <a:tr h="658368">
-                <a:tc>
-                  <a:txBody>
-                    <a:bodyPr/>
-                    <a:lstStyle/>
-                    <a:p>
-                      <a:pPr indent="0" marL="0">
-                        <a:buNone/>
-                      </a:pPr>
-                      <a:r>
-                        <a:rPr lang="en-US" sz="1250" dirty="0">
-                          <a:solidFill>
-                            <a:srgbClr val="000000"/>
-                          </a:solidFill>
-                          <a:latin typeface="Microsoft YaHei" pitchFamily="34" charset="0"/>
-                          <a:ea typeface="Microsoft YaHei" pitchFamily="34" charset="-122"/>
-                          <a:cs typeface="Microsoft YaHei" pitchFamily="34" charset="-120"/>
-                        </a:rPr>
-                        <a:t>MDA5 蛋白</a:t>
-                      </a:r>
-                      <a:endParaRPr lang="en-US" sz="1250" dirty="0">
-                        <a:latin typeface="Microsoft YaHei" charset="0"/>
-                        <a:ea typeface="Microsoft YaHei" charset="0"/>
-                        <a:cs typeface="Microsoft YaHei" charset="0"/>
-                      </a:endParaRPr>
-                    </a:p>
-                  </a:txBody>
-                  <a:tcPr marL="91440" marR="91440" marT="45720" marB="45720" anchor="ctr">
-                    <a:lnL w="0" cap="flat" cmpd="sng" algn="ctr">
-                      <a:noFill/>
-                    </a:lnL>
-                    <a:lnR w="0" cap="flat" cmpd="sng" algn="ctr">
-                      <a:noFill/>
-                    </a:lnR>
-                    <a:lnT w="0" cap="flat" cmpd="sng" algn="ctr">
-                      <a:noFill/>
-                    </a:lnT>
-                    <a:lnB w="12700" cap="flat" cmpd="sng" algn="ctr">
-                      <a:solidFill>
-                        <a:srgbClr val="C8CCD2"/>
-                      </a:solidFill>
-                      <a:prstDash val="solid"/>
-                      <a:round/>
-                      <a:headEnd type="none" w="med" len="med"/>
-                      <a:tailEnd type="none" w="med" len="med"/>
-                    </a:lnB>
-                  </a:tcPr>
-                </a:tc>
-                <a:tc>
-                  <a:txBody>
-                    <a:bodyPr/>
-                    <a:lstStyle/>
-                    <a:p>
-                      <a:pPr indent="0" marL="0">
-                        <a:buNone/>
-                      </a:pPr>
-                      <a:r>
-                        <a:rPr lang="en-US" sz="1250" dirty="0">
-                          <a:solidFill>
-                            <a:srgbClr val="000000"/>
-                          </a:solidFill>
-                          <a:latin typeface="Microsoft YaHei" pitchFamily="34" charset="0"/>
-                          <a:ea typeface="Microsoft YaHei" pitchFamily="34" charset="-122"/>
-                          <a:cs typeface="Microsoft YaHei" pitchFamily="34" charset="-120"/>
-                        </a:rPr>
-                        <a:t>人类 MS 脑组织的免疫组化与蛋白质组测量为零篇</a:t>
-                      </a:r>
-                      <a:endParaRPr lang="en-US" sz="1250" dirty="0">
-                        <a:latin typeface="Microsoft YaHei" charset="0"/>
-                        <a:ea typeface="Microsoft YaHei" charset="0"/>
-                        <a:cs typeface="Microsoft YaHei" charset="0"/>
-                      </a:endParaRPr>
-                    </a:p>
-                  </a:txBody>
-                  <a:tcPr marL="91440" marR="91440" marT="45720" marB="45720" anchor="ctr">
-                    <a:lnL w="0" cap="flat" cmpd="sng" algn="ctr">
-                      <a:noFill/>
-                    </a:lnL>
-                    <a:lnR w="0" cap="flat" cmpd="sng" algn="ctr">
-                      <a:noFill/>
-                    </a:lnR>
-                    <a:lnT w="0" cap="flat" cmpd="sng" algn="ctr">
-                      <a:noFill/>
-                    </a:lnT>
-                    <a:lnB w="12700" cap="flat" cmpd="sng" algn="ctr">
-                      <a:solidFill>
-                        <a:srgbClr val="C8CCD2"/>
-                      </a:solidFill>
-                      <a:prstDash val="solid"/>
-                      <a:round/>
-                      <a:headEnd type="none" w="med" len="med"/>
-                      <a:tailEnd type="none" w="med" len="med"/>
-                    </a:lnB>
-                  </a:tcPr>
-                </a:tc>
-              </a:tr>
-            </a:tbl>
-          </a:graphicData>
-        </a:graphic>
-      </p:graphicFrame>
-    </p:spTree>
-  </p:cSld>
-  <p:clrMapOvr>
-    <a:masterClrMapping/>
-  </p:clrMapOvr>
-</p:sld>
-</file>
-
-<file path=ppt/slides/slide12.xml><?xml version="1.0" encoding="utf-8"?>
-<p:sld xmlns:a="http://schemas.openxmlformats.org/drawingml/2006/main" xmlns:r="http://schemas.openxmlformats.org/officeDocument/2006/relationships" xmlns:p="http://schemas.openxmlformats.org/presentationml/2006/main">
-  <p:cSld name="Slide 12">
-    <p:spTree>
-      <p:nvGrpSpPr>
-        <p:cNvPr id="1" name=""/>
-        <p:cNvGrpSpPr/>
-        <p:nvPr/>
-      </p:nvGrpSpPr>
-      <p:grpSpPr>
-        <a:xfrm>
-          <a:off x="0" y="0"/>
-          <a:ext cx="0" cy="0"/>
-          <a:chOff x="0" y="0"/>
-          <a:chExt cx="0" cy="0"/>
-        </a:xfrm>
-      </p:grpSpPr>
-      <p:sp>
-        <p:nvSpPr>
-          <p:cNvPr id="2" name="Text 0"/>
-          <p:cNvSpPr txBox="1"/>
-          <p:nvPr/>
-        </p:nvSpPr>
-        <p:spPr>
-          <a:xfrm>
-            <a:off x="11430000" y="6355080"/>
-            <a:ext cx="457200" cy="274320"/>
-          </a:xfrm>
-          <a:prstGeom prst="rect">
-            <a:avLst/>
-          </a:prstGeom>
-          <a:noFill/>
-          <a:ln/>
-        </p:spPr>
-        <p:txBody>
-          <a:bodyPr wrap="square" lIns="0" tIns="0" rIns="0" bIns="0" rtlCol="0" anchor="ctr"/>
-          <a:lstStyle/>
-          <a:p>
-            <a:pPr algn="r" indent="0" marL="0">
-              <a:buNone/>
-            </a:pPr>
-            <a:r>
-              <a:rPr lang="en-US" sz="1000" dirty="0">
-                <a:solidFill>
-                  <a:srgbClr val="6E6E6E"/>
-                </a:solidFill>
-                <a:latin typeface="Calibri" pitchFamily="34" charset="0"/>
-                <a:ea typeface="Calibri" pitchFamily="34" charset="-122"/>
-                <a:cs typeface="Calibri" pitchFamily="34" charset="-120"/>
-              </a:rPr>
-              <a:t>11</a:t>
-            </a:r>
-            <a:endParaRPr lang="en-US" sz="1000" dirty="0"/>
-          </a:p>
-        </p:txBody>
-      </p:sp>
-      <p:sp>
-        <p:nvSpPr>
-          <p:cNvPr id="3" name="Text 1"/>
-          <p:cNvSpPr txBox="1"/>
-          <p:nvPr/>
-        </p:nvSpPr>
-        <p:spPr>
-          <a:xfrm>
-            <a:off x="548640" y="274320"/>
-            <a:ext cx="11064240" cy="475488"/>
-          </a:xfrm>
-          <a:prstGeom prst="rect">
-            <a:avLst/>
-          </a:prstGeom>
-          <a:noFill/>
-          <a:ln/>
-        </p:spPr>
-        <p:txBody>
-          <a:bodyPr wrap="square" lIns="0" tIns="0" rIns="0" bIns="0" rtlCol="0" anchor="ctr"/>
-          <a:lstStyle/>
-          <a:p>
-            <a:pPr indent="0" marL="0">
-              <a:buNone/>
-            </a:pPr>
-            <a:r>
-              <a:rPr lang="en-US" sz="2500" b="1" dirty="0">
-                <a:solidFill>
-                  <a:srgbClr val="000000"/>
-                </a:solidFill>
-                <a:latin typeface="Microsoft YaHei" pitchFamily="34" charset="0"/>
-                <a:ea typeface="Microsoft YaHei" pitchFamily="34" charset="-122"/>
-                <a:cs typeface="Microsoft YaHei" pitchFamily="34" charset="-120"/>
-              </a:rPr>
-              <a:t>局限</a:t>
-            </a:r>
-            <a:endParaRPr lang="en-US" sz="2500" dirty="0"/>
-          </a:p>
-        </p:txBody>
-      </p:sp>
-      <p:sp>
-        <p:nvSpPr>
-          <p:cNvPr id="4" name="Text 2"/>
-          <p:cNvSpPr txBox="1"/>
-          <p:nvPr/>
-        </p:nvSpPr>
-        <p:spPr>
-          <a:xfrm>
-            <a:off x="548640" y="1005840"/>
-            <a:ext cx="3566160" cy="365760"/>
-          </a:xfrm>
-          <a:prstGeom prst="rect">
-            <a:avLst/>
-          </a:prstGeom>
-          <a:noFill/>
-          <a:ln/>
-        </p:spPr>
-        <p:txBody>
-          <a:bodyPr wrap="square" lIns="0" tIns="0" rIns="0" bIns="0" rtlCol="0" anchor="ctr"/>
-          <a:lstStyle/>
-          <a:p>
-            <a:pPr indent="0" marL="0">
-              <a:buNone/>
-            </a:pPr>
-            <a:r>
-              <a:rPr lang="en-US" sz="1350" b="1" dirty="0">
-                <a:solidFill>
-                  <a:srgbClr val="000000"/>
-                </a:solidFill>
-                <a:latin typeface="Microsoft YaHei" pitchFamily="34" charset="0"/>
-                <a:ea typeface="Microsoft YaHei" pitchFamily="34" charset="-122"/>
-                <a:cs typeface="Microsoft YaHei" pitchFamily="34" charset="-120"/>
-              </a:rPr>
-              <a:t>皮层标本含白质成分</a:t>
-            </a:r>
-            <a:endParaRPr lang="en-US" sz="1350" dirty="0"/>
-          </a:p>
-        </p:txBody>
-      </p:sp>
-      <p:sp>
-        <p:nvSpPr>
-          <p:cNvPr id="5" name="Text 3"/>
-          <p:cNvSpPr txBox="1"/>
-          <p:nvPr/>
-        </p:nvSpPr>
-        <p:spPr>
-          <a:xfrm>
-            <a:off x="4251960" y="1005840"/>
-            <a:ext cx="7406640" cy="566928"/>
-          </a:xfrm>
-          <a:prstGeom prst="rect">
-            <a:avLst/>
-          </a:prstGeom>
-          <a:noFill/>
-          <a:ln/>
-        </p:spPr>
-        <p:txBody>
-          <a:bodyPr wrap="square" lIns="0" tIns="0" rIns="0" bIns="0" rtlCol="0" anchor="ctr"/>
-          <a:lstStyle/>
-          <a:p>
-            <a:pPr indent="0" marL="0">
-              <a:lnSpc>
-                <a:spcPts val="1600"/>
-              </a:lnSpc>
-              <a:buNone/>
-            </a:pPr>
-            <a:r>
-              <a:rPr lang="en-US" sz="1200" dirty="0">
-                <a:solidFill>
-                  <a:srgbClr val="6E6E6E"/>
-                </a:solidFill>
-                <a:latin typeface="Microsoft YaHei" pitchFamily="34" charset="0"/>
-                <a:ea typeface="Microsoft YaHei" pitchFamily="34" charset="-122"/>
-                <a:cs typeface="Microsoft YaHei" pitchFamily="34" charset="-120"/>
-              </a:rPr>
-              <a:t>Schirmer 取材跨越皮层全层并带有其下的皮层下白质，MS 标本取材更深，疾病对比与取材部位混杂。</a:t>
-            </a:r>
-            <a:endParaRPr lang="en-US" sz="1200" dirty="0"/>
-          </a:p>
-        </p:txBody>
-      </p:sp>
-      <p:sp>
-        <p:nvSpPr>
-          <p:cNvPr id="6" name="Text 4"/>
-          <p:cNvSpPr txBox="1"/>
-          <p:nvPr/>
-        </p:nvSpPr>
-        <p:spPr>
-          <a:xfrm>
-            <a:off x="548640" y="1737360"/>
-            <a:ext cx="3566160" cy="365760"/>
-          </a:xfrm>
-          <a:prstGeom prst="rect">
-            <a:avLst/>
-          </a:prstGeom>
-          <a:noFill/>
-          <a:ln/>
-        </p:spPr>
-        <p:txBody>
-          <a:bodyPr wrap="square" lIns="0" tIns="0" rIns="0" bIns="0" rtlCol="0" anchor="ctr"/>
-          <a:lstStyle/>
-          <a:p>
-            <a:pPr indent="0" marL="0">
-              <a:buNone/>
-            </a:pPr>
-            <a:r>
-              <a:rPr lang="en-US" sz="1350" b="1" dirty="0">
-                <a:solidFill>
-                  <a:srgbClr val="000000"/>
-                </a:solidFill>
-                <a:latin typeface="Microsoft YaHei" pitchFamily="34" charset="0"/>
-                <a:ea typeface="Microsoft YaHei" pitchFamily="34" charset="-122"/>
-                <a:cs typeface="Microsoft YaHei" pitchFamily="34" charset="-120"/>
-              </a:rPr>
-              <a:t>区域交互仅两类可估计</a:t>
-            </a:r>
-            <a:endParaRPr lang="en-US" sz="1350" dirty="0"/>
-          </a:p>
-        </p:txBody>
-      </p:sp>
-      <p:sp>
-        <p:nvSpPr>
-          <p:cNvPr id="7" name="Text 5"/>
-          <p:cNvSpPr txBox="1"/>
-          <p:nvPr/>
-        </p:nvSpPr>
-        <p:spPr>
-          <a:xfrm>
-            <a:off x="4251960" y="1737360"/>
-            <a:ext cx="7406640" cy="566928"/>
-          </a:xfrm>
-          <a:prstGeom prst="rect">
-            <a:avLst/>
-          </a:prstGeom>
-          <a:noFill/>
-          <a:ln/>
-        </p:spPr>
-        <p:txBody>
-          <a:bodyPr wrap="square" lIns="0" tIns="0" rIns="0" bIns="0" rtlCol="0" anchor="ctr"/>
-          <a:lstStyle/>
-          <a:p>
-            <a:pPr indent="0" marL="0">
-              <a:lnSpc>
-                <a:spcPts val="1600"/>
-              </a:lnSpc>
-              <a:buNone/>
-            </a:pPr>
-            <a:r>
-              <a:rPr lang="en-US" sz="1200" dirty="0">
-                <a:solidFill>
-                  <a:srgbClr val="6E6E6E"/>
-                </a:solidFill>
-                <a:latin typeface="Microsoft YaHei" pitchFamily="34" charset="0"/>
-                <a:ea typeface="Microsoft YaHei" pitchFamily="34" charset="-122"/>
-                <a:cs typeface="Microsoft YaHei" pitchFamily="34" charset="-120"/>
-              </a:rPr>
-              <a:t>小胶质细胞、神经元、内皮细胞因一侧样本量不足，少突胶质前体细胞因对照组未检出。</a:t>
-            </a:r>
-            <a:endParaRPr lang="en-US" sz="1200" dirty="0"/>
-          </a:p>
-        </p:txBody>
-      </p:sp>
-      <p:sp>
-        <p:nvSpPr>
-          <p:cNvPr id="8" name="Text 6"/>
-          <p:cNvSpPr txBox="1"/>
-          <p:nvPr/>
-        </p:nvSpPr>
-        <p:spPr>
-          <a:xfrm>
-            <a:off x="548640" y="2468880"/>
-            <a:ext cx="3566160" cy="365760"/>
-          </a:xfrm>
-          <a:prstGeom prst="rect">
-            <a:avLst/>
-          </a:prstGeom>
-          <a:noFill/>
-          <a:ln/>
-        </p:spPr>
-        <p:txBody>
-          <a:bodyPr wrap="square" lIns="0" tIns="0" rIns="0" bIns="0" rtlCol="0" anchor="ctr"/>
-          <a:lstStyle/>
-          <a:p>
-            <a:pPr indent="0" marL="0">
-              <a:buNone/>
-            </a:pPr>
-            <a:r>
-              <a:rPr lang="en-US" sz="1350" b="1" dirty="0">
-                <a:solidFill>
-                  <a:srgbClr val="000000"/>
-                </a:solidFill>
-                <a:latin typeface="Microsoft YaHei" pitchFamily="34" charset="0"/>
-                <a:ea typeface="Microsoft YaHei" pitchFamily="34" charset="-122"/>
-                <a:cs typeface="Microsoft YaHei" pitchFamily="34" charset="-120"/>
-              </a:rPr>
-              <a:t>白质结论主要由一个队列支持</a:t>
-            </a:r>
-            <a:endParaRPr lang="en-US" sz="1350" dirty="0"/>
-          </a:p>
-        </p:txBody>
-      </p:sp>
-      <p:sp>
-        <p:nvSpPr>
-          <p:cNvPr id="9" name="Text 7"/>
-          <p:cNvSpPr txBox="1"/>
-          <p:nvPr/>
-        </p:nvSpPr>
-        <p:spPr>
-          <a:xfrm>
-            <a:off x="4251960" y="2468880"/>
-            <a:ext cx="7406640" cy="566928"/>
-          </a:xfrm>
-          <a:prstGeom prst="rect">
-            <a:avLst/>
-          </a:prstGeom>
-          <a:noFill/>
-          <a:ln/>
-        </p:spPr>
-        <p:txBody>
-          <a:bodyPr wrap="square" lIns="0" tIns="0" rIns="0" bIns="0" rtlCol="0" anchor="ctr"/>
-          <a:lstStyle/>
-          <a:p>
-            <a:pPr indent="0" marL="0">
-              <a:lnSpc>
-                <a:spcPts val="1600"/>
-              </a:lnSpc>
-              <a:buNone/>
-            </a:pPr>
-            <a:r>
-              <a:rPr lang="en-US" sz="1200" dirty="0">
-                <a:solidFill>
-                  <a:srgbClr val="6E6E6E"/>
-                </a:solidFill>
-                <a:latin typeface="Microsoft YaHei" pitchFamily="34" charset="0"/>
-                <a:ea typeface="Microsoft YaHei" pitchFamily="34" charset="-122"/>
-                <a:cs typeface="Microsoft YaHei" pitchFamily="34" charset="-120"/>
-              </a:rPr>
-              <a:t>GSE279180 十三例供体，3.5 倍，区间 [1.5, 4.9]；GSE180759 仅三例对照，1.5 倍，区间包含 1。</a:t>
-            </a:r>
-            <a:endParaRPr lang="en-US" sz="1200" dirty="0"/>
-          </a:p>
-        </p:txBody>
-      </p:sp>
-      <p:sp>
-        <p:nvSpPr>
-          <p:cNvPr id="10" name="Text 8"/>
-          <p:cNvSpPr txBox="1"/>
-          <p:nvPr/>
-        </p:nvSpPr>
-        <p:spPr>
-          <a:xfrm>
-            <a:off x="548640" y="3200400"/>
-            <a:ext cx="3566160" cy="365760"/>
-          </a:xfrm>
-          <a:prstGeom prst="rect">
-            <a:avLst/>
-          </a:prstGeom>
-          <a:noFill/>
-          <a:ln/>
-        </p:spPr>
-        <p:txBody>
-          <a:bodyPr wrap="square" lIns="0" tIns="0" rIns="0" bIns="0" rtlCol="0" anchor="ctr"/>
-          <a:lstStyle/>
-          <a:p>
-            <a:pPr indent="0" marL="0">
-              <a:buNone/>
-            </a:pPr>
-            <a:r>
-              <a:rPr lang="en-US" sz="1350" b="1" dirty="0">
-                <a:solidFill>
-                  <a:srgbClr val="000000"/>
-                </a:solidFill>
-                <a:latin typeface="Microsoft YaHei" pitchFamily="34" charset="0"/>
-                <a:ea typeface="Microsoft YaHei" pitchFamily="34" charset="-122"/>
-                <a:cs typeface="Microsoft YaHei" pitchFamily="34" charset="-120"/>
-              </a:rPr>
-              <a:t>测序深度残余影响</a:t>
-            </a:r>
-            <a:endParaRPr lang="en-US" sz="1350" dirty="0"/>
-          </a:p>
-        </p:txBody>
-      </p:sp>
-      <p:sp>
-        <p:nvSpPr>
-          <p:cNvPr id="11" name="Text 9"/>
-          <p:cNvSpPr txBox="1"/>
-          <p:nvPr/>
-        </p:nvSpPr>
-        <p:spPr>
-          <a:xfrm>
-            <a:off x="4251960" y="3200400"/>
-            <a:ext cx="7406640" cy="566928"/>
-          </a:xfrm>
-          <a:prstGeom prst="rect">
-            <a:avLst/>
-          </a:prstGeom>
-          <a:noFill/>
-          <a:ln/>
-        </p:spPr>
-        <p:txBody>
-          <a:bodyPr wrap="square" lIns="0" tIns="0" rIns="0" bIns="0" rtlCol="0" anchor="ctr"/>
-          <a:lstStyle/>
-          <a:p>
-            <a:pPr indent="0" marL="0">
-              <a:lnSpc>
-                <a:spcPts val="1600"/>
-              </a:lnSpc>
-              <a:buNone/>
-            </a:pPr>
-            <a:r>
-              <a:rPr lang="en-US" sz="1200" dirty="0">
-                <a:solidFill>
-                  <a:srgbClr val="6E6E6E"/>
-                </a:solidFill>
-                <a:latin typeface="Microsoft YaHei" pitchFamily="34" charset="0"/>
-                <a:ea typeface="Microsoft YaHei" pitchFamily="34" charset="-122"/>
-                <a:cs typeface="Microsoft YaHei" pitchFamily="34" charset="-120"/>
-              </a:rPr>
-              <a:t>已限定在每核 1500 至 5000 UMI 的共同深度区间内比较，区间内仍存在残余差异。</a:t>
-            </a:r>
-            <a:endParaRPr lang="en-US" sz="1200" dirty="0"/>
-          </a:p>
-        </p:txBody>
-      </p:sp>
-      <p:sp>
-        <p:nvSpPr>
-          <p:cNvPr id="12" name="Text 10"/>
-          <p:cNvSpPr txBox="1"/>
-          <p:nvPr/>
-        </p:nvSpPr>
-        <p:spPr>
-          <a:xfrm>
-            <a:off x="548640" y="3931920"/>
-            <a:ext cx="3566160" cy="365760"/>
-          </a:xfrm>
-          <a:prstGeom prst="rect">
-            <a:avLst/>
-          </a:prstGeom>
-          <a:noFill/>
-          <a:ln/>
-        </p:spPr>
-        <p:txBody>
-          <a:bodyPr wrap="square" lIns="0" tIns="0" rIns="0" bIns="0" rtlCol="0" anchor="ctr"/>
-          <a:lstStyle/>
-          <a:p>
-            <a:pPr indent="0" marL="0">
-              <a:buNone/>
-            </a:pPr>
-            <a:r>
-              <a:rPr lang="en-US" sz="1350" b="1" dirty="0">
-                <a:solidFill>
-                  <a:srgbClr val="000000"/>
-                </a:solidFill>
-                <a:latin typeface="Microsoft YaHei" pitchFamily="34" charset="0"/>
-                <a:ea typeface="Microsoft YaHei" pitchFamily="34" charset="-122"/>
-                <a:cs typeface="Microsoft YaHei" pitchFamily="34" charset="-120"/>
-              </a:rPr>
-              <a:t>GSE180759 存在平台混杂</a:t>
-            </a:r>
-            <a:endParaRPr lang="en-US" sz="1350" dirty="0"/>
-          </a:p>
-        </p:txBody>
-      </p:sp>
-      <p:sp>
-        <p:nvSpPr>
-          <p:cNvPr id="13" name="Text 11"/>
-          <p:cNvSpPr txBox="1"/>
-          <p:nvPr/>
-        </p:nvSpPr>
-        <p:spPr>
-          <a:xfrm>
-            <a:off x="4251960" y="3931920"/>
-            <a:ext cx="7406640" cy="566928"/>
-          </a:xfrm>
-          <a:prstGeom prst="rect">
-            <a:avLst/>
-          </a:prstGeom>
-          <a:noFill/>
-          <a:ln/>
-        </p:spPr>
-        <p:txBody>
-          <a:bodyPr wrap="square" lIns="0" tIns="0" rIns="0" bIns="0" rtlCol="0" anchor="ctr"/>
-          <a:lstStyle/>
-          <a:p>
-            <a:pPr indent="0" marL="0">
-              <a:lnSpc>
-                <a:spcPts val="1600"/>
-              </a:lnSpc>
-              <a:buNone/>
-            </a:pPr>
-            <a:r>
-              <a:rPr lang="en-US" sz="1200" dirty="0">
-                <a:solidFill>
-                  <a:srgbClr val="6E6E6E"/>
-                </a:solidFill>
-                <a:latin typeface="Microsoft YaHei" pitchFamily="34" charset="0"/>
-                <a:ea typeface="Microsoft YaHei" pitchFamily="34" charset="-122"/>
-                <a:cs typeface="Microsoft YaHei" pitchFamily="34" charset="-120"/>
-              </a:rPr>
-              <a:t>病灶周围白质文库全为 NovaSeq，病灶边缘文库全为 HiSeq；图谱已按文库做 Harmony 整合。</a:t>
-            </a:r>
-            <a:endParaRPr lang="en-US" sz="1200" dirty="0"/>
-          </a:p>
-        </p:txBody>
-      </p:sp>
-      <p:sp>
-        <p:nvSpPr>
-          <p:cNvPr id="14" name="Text 12"/>
-          <p:cNvSpPr txBox="1"/>
-          <p:nvPr/>
-        </p:nvSpPr>
-        <p:spPr>
-          <a:xfrm>
-            <a:off x="548640" y="4663440"/>
-            <a:ext cx="3566160" cy="365760"/>
-          </a:xfrm>
-          <a:prstGeom prst="rect">
-            <a:avLst/>
-          </a:prstGeom>
-          <a:noFill/>
-          <a:ln/>
-        </p:spPr>
-        <p:txBody>
-          <a:bodyPr wrap="square" lIns="0" tIns="0" rIns="0" bIns="0" rtlCol="0" anchor="ctr"/>
-          <a:lstStyle/>
-          <a:p>
-            <a:pPr indent="0" marL="0">
-              <a:buNone/>
-            </a:pPr>
-            <a:r>
-              <a:rPr lang="en-US" sz="1350" b="1" dirty="0">
-                <a:solidFill>
-                  <a:srgbClr val="000000"/>
-                </a:solidFill>
-                <a:latin typeface="Microsoft YaHei" pitchFamily="34" charset="0"/>
-                <a:ea typeface="Microsoft YaHei" pitchFamily="34" charset="-122"/>
-                <a:cs typeface="Microsoft YaHei" pitchFamily="34" charset="-120"/>
-              </a:rPr>
-              <a:t>以阳性核比例而非表达量</a:t>
-            </a:r>
-            <a:endParaRPr lang="en-US" sz="1350" dirty="0"/>
-          </a:p>
-        </p:txBody>
-      </p:sp>
-      <p:sp>
-        <p:nvSpPr>
-          <p:cNvPr id="15" name="Text 13"/>
-          <p:cNvSpPr txBox="1"/>
-          <p:nvPr/>
-        </p:nvSpPr>
-        <p:spPr>
-          <a:xfrm>
-            <a:off x="4251960" y="4663440"/>
-            <a:ext cx="7406640" cy="566928"/>
-          </a:xfrm>
-          <a:prstGeom prst="rect">
-            <a:avLst/>
-          </a:prstGeom>
-          <a:noFill/>
-          <a:ln/>
-        </p:spPr>
-        <p:txBody>
-          <a:bodyPr wrap="square" lIns="0" tIns="0" rIns="0" bIns="0" rtlCol="0" anchor="ctr"/>
-          <a:lstStyle/>
-          <a:p>
-            <a:pPr indent="0" marL="0">
-              <a:lnSpc>
-                <a:spcPts val="1600"/>
-              </a:lnSpc>
-              <a:buNone/>
-            </a:pPr>
-            <a:r>
-              <a:rPr lang="en-US" sz="1200" dirty="0">
-                <a:solidFill>
-                  <a:srgbClr val="6E6E6E"/>
-                </a:solidFill>
-                <a:latin typeface="Microsoft YaHei" pitchFamily="34" charset="0"/>
-                <a:ea typeface="Microsoft YaHei" pitchFamily="34" charset="-122"/>
-                <a:cs typeface="Microsoft YaHei" pitchFamily="34" charset="-120"/>
-              </a:rPr>
-              <a:t>Schirmer 仅提供对数归一化矩阵，标度因子不可恢复，跨队列表达量不可比。</a:t>
-            </a:r>
-            <a:endParaRPr lang="en-US" sz="1200" dirty="0"/>
-          </a:p>
-        </p:txBody>
-      </p:sp>
-      <p:sp>
-        <p:nvSpPr>
-          <p:cNvPr id="16" name="Text 14"/>
-          <p:cNvSpPr txBox="1"/>
-          <p:nvPr/>
-        </p:nvSpPr>
-        <p:spPr>
-          <a:xfrm>
-            <a:off x="548640" y="5394960"/>
-            <a:ext cx="3566160" cy="365760"/>
-          </a:xfrm>
-          <a:prstGeom prst="rect">
-            <a:avLst/>
-          </a:prstGeom>
-          <a:noFill/>
-          <a:ln/>
-        </p:spPr>
-        <p:txBody>
-          <a:bodyPr wrap="square" lIns="0" tIns="0" rIns="0" bIns="0" rtlCol="0" anchor="ctr"/>
-          <a:lstStyle/>
-          <a:p>
-            <a:pPr indent="0" marL="0">
-              <a:buNone/>
-            </a:pPr>
-            <a:r>
-              <a:rPr lang="en-US" sz="1350" b="1" dirty="0">
-                <a:solidFill>
-                  <a:srgbClr val="000000"/>
-                </a:solidFill>
-                <a:latin typeface="Microsoft YaHei" pitchFamily="34" charset="0"/>
-                <a:ea typeface="Microsoft YaHei" pitchFamily="34" charset="-122"/>
-                <a:cs typeface="Microsoft YaHei" pitchFamily="34" charset="-120"/>
-              </a:rPr>
-              <a:t>仅限转录本水平</a:t>
-            </a:r>
-            <a:endParaRPr lang="en-US" sz="1350" dirty="0"/>
-          </a:p>
-        </p:txBody>
-      </p:sp>
-      <p:sp>
-        <p:nvSpPr>
-          <p:cNvPr id="17" name="Text 15"/>
-          <p:cNvSpPr txBox="1"/>
-          <p:nvPr/>
-        </p:nvSpPr>
-        <p:spPr>
-          <a:xfrm>
-            <a:off x="4251960" y="5394960"/>
-            <a:ext cx="7406640" cy="566928"/>
-          </a:xfrm>
-          <a:prstGeom prst="rect">
-            <a:avLst/>
-          </a:prstGeom>
-          <a:noFill/>
-          <a:ln/>
-        </p:spPr>
-        <p:txBody>
-          <a:bodyPr wrap="square" lIns="0" tIns="0" rIns="0" bIns="0" rtlCol="0" anchor="ctr"/>
-          <a:lstStyle/>
-          <a:p>
-            <a:pPr indent="0" marL="0">
-              <a:lnSpc>
-                <a:spcPts val="1600"/>
-              </a:lnSpc>
-              <a:buNone/>
-            </a:pPr>
-            <a:r>
-              <a:rPr lang="en-US" sz="1200" dirty="0">
-                <a:solidFill>
-                  <a:srgbClr val="6E6E6E"/>
-                </a:solidFill>
-                <a:latin typeface="Microsoft YaHei" pitchFamily="34" charset="0"/>
-                <a:ea typeface="Microsoft YaHei" pitchFamily="34" charset="-122"/>
-                <a:cs typeface="Microsoft YaHei" pitchFamily="34" charset="-120"/>
-              </a:rPr>
-              <a:t>人类 MS 脑组织尚无 MDA5 蛋白水平的测量。</a:t>
-            </a:r>
-            <a:endParaRPr lang="en-US" sz="1200" dirty="0"/>
-          </a:p>
-        </p:txBody>
-      </p:sp>
-    </p:spTree>
-  </p:cSld>
-  <p:clrMapOvr>
-    <a:masterClrMapping/>
-  </p:clrMapOvr>
-</p:sld>
-</file>
-
 <file path=ppt/slides/slide2.xml><?xml version="1.0" encoding="utf-8"?>
 <p:sld xmlns:a="http://schemas.openxmlformats.org/drawingml/2006/main" xmlns:r="http://schemas.openxmlformats.org/officeDocument/2006/relationships" xmlns:p="http://schemas.openxmlformats.org/presentationml/2006/main">
   <p:cSld name="Slide 2">
@@ -5610,133 +3645,6 @@
                 <a:ea typeface="Microsoft YaHei" pitchFamily="34" charset="-122"/>
                 <a:cs typeface="Microsoft YaHei" pitchFamily="34" charset="-120"/>
               </a:rPr>
-              <a:t>跨研究偏移的稳健性检验</a:t>
-            </a:r>
-            <a:endParaRPr lang="en-US" sz="2500" dirty="0"/>
-          </a:p>
-        </p:txBody>
-      </p:sp>
-      <p:pic>
-        <p:nvPicPr>
-          <p:cNvPr id="4" name="Image 0" descr="/home/user/aaa/results/mda5/figs/figB_null.png">    </p:cNvPr>
-          <p:cNvPicPr>
-            <a:picLocks noChangeAspect="1"/>
-          </p:cNvPicPr>
-          <p:nvPr/>
-        </p:nvPicPr>
-        <p:blipFill>
-          <a:blip r:embed="rId1"/>
-          <a:stretch>
-            <a:fillRect/>
-          </a:stretch>
-        </p:blipFill>
-        <p:spPr>
-          <a:xfrm>
-            <a:off x="963367" y="960120"/>
-            <a:ext cx="10280507" cy="5513832"/>
-          </a:xfrm>
-          <a:prstGeom prst="rect">
-            <a:avLst/>
-          </a:prstGeom>
-        </p:spPr>
-      </p:pic>
-    </p:spTree>
-  </p:cSld>
-  <p:clrMapOvr>
-    <a:masterClrMapping/>
-  </p:clrMapOvr>
-</p:sld>
-</file>
-
-<file path=ppt/slides/slide6.xml><?xml version="1.0" encoding="utf-8"?>
-<p:sld xmlns:a="http://schemas.openxmlformats.org/drawingml/2006/main" xmlns:r="http://schemas.openxmlformats.org/officeDocument/2006/relationships" xmlns:p="http://schemas.openxmlformats.org/presentationml/2006/main">
-  <p:cSld name="Slide 6">
-    <p:spTree>
-      <p:nvGrpSpPr>
-        <p:cNvPr id="1" name=""/>
-        <p:cNvGrpSpPr/>
-        <p:nvPr/>
-      </p:nvGrpSpPr>
-      <p:grpSpPr>
-        <a:xfrm>
-          <a:off x="0" y="0"/>
-          <a:ext cx="0" cy="0"/>
-          <a:chOff x="0" y="0"/>
-          <a:chExt cx="0" cy="0"/>
-        </a:xfrm>
-      </p:grpSpPr>
-      <p:sp>
-        <p:nvSpPr>
-          <p:cNvPr id="2" name="Text 0"/>
-          <p:cNvSpPr txBox="1"/>
-          <p:nvPr/>
-        </p:nvSpPr>
-        <p:spPr>
-          <a:xfrm>
-            <a:off x="11430000" y="6355080"/>
-            <a:ext cx="457200" cy="274320"/>
-          </a:xfrm>
-          <a:prstGeom prst="rect">
-            <a:avLst/>
-          </a:prstGeom>
-          <a:noFill/>
-          <a:ln/>
-        </p:spPr>
-        <p:txBody>
-          <a:bodyPr wrap="square" lIns="0" tIns="0" rIns="0" bIns="0" rtlCol="0" anchor="ctr"/>
-          <a:lstStyle/>
-          <a:p>
-            <a:pPr algn="r" indent="0" marL="0">
-              <a:buNone/>
-            </a:pPr>
-            <a:r>
-              <a:rPr lang="en-US" sz="1000" dirty="0">
-                <a:solidFill>
-                  <a:srgbClr val="6E6E6E"/>
-                </a:solidFill>
-                <a:latin typeface="Calibri" pitchFamily="34" charset="0"/>
-                <a:ea typeface="Calibri" pitchFamily="34" charset="-122"/>
-                <a:cs typeface="Calibri" pitchFamily="34" charset="-120"/>
-              </a:rPr>
-              <a:t>5</a:t>
-            </a:r>
-            <a:endParaRPr lang="en-US" sz="1000" dirty="0"/>
-          </a:p>
-        </p:txBody>
-      </p:sp>
-      <p:sp>
-        <p:nvSpPr>
-          <p:cNvPr id="3" name="Text 1"/>
-          <p:cNvSpPr txBox="1"/>
-          <p:nvPr/>
-        </p:nvSpPr>
-        <p:spPr>
-          <a:xfrm>
-            <a:off x="548640" y="274320"/>
-            <a:ext cx="11064240" cy="475488"/>
-          </a:xfrm>
-          <a:prstGeom prst="rect">
-            <a:avLst/>
-          </a:prstGeom>
-          <a:noFill/>
-          <a:ln/>
-        </p:spPr>
-        <p:txBody>
-          <a:bodyPr wrap="square" lIns="0" tIns="0" rIns="0" bIns="0" rtlCol="0" anchor="ctr"/>
-          <a:lstStyle/>
-          <a:p>
-            <a:pPr indent="0" marL="0">
-              <a:buNone/>
-            </a:pPr>
-            <a:r>
-              <a:rPr lang="en-US" sz="2500" b="1" dirty="0">
-                <a:solidFill>
-                  <a:srgbClr val="000000"/>
-                </a:solidFill>
-                <a:latin typeface="Microsoft YaHei" pitchFamily="34" charset="0"/>
-                <a:ea typeface="Microsoft YaHei" pitchFamily="34" charset="-122"/>
-                <a:cs typeface="Microsoft YaHei" pitchFamily="34" charset="-120"/>
-              </a:rPr>
               <a:t>MS 白质：少突胶质细胞 IFIH1 阳性率升高</a:t>
             </a:r>
             <a:endParaRPr lang="en-US" sz="2500" dirty="0"/>
@@ -5775,9 +3683,9 @@
 </p:sld>
 </file>
 
-<file path=ppt/slides/slide7.xml><?xml version="1.0" encoding="utf-8"?>
+<file path=ppt/slides/slide6.xml><?xml version="1.0" encoding="utf-8"?>
 <p:sld xmlns:a="http://schemas.openxmlformats.org/drawingml/2006/main" xmlns:r="http://schemas.openxmlformats.org/officeDocument/2006/relationships" xmlns:p="http://schemas.openxmlformats.org/presentationml/2006/main">
-  <p:cSld name="Slide 7">
+  <p:cSld name="Slide 6">
     <p:spTree>
       <p:nvGrpSpPr>
         <p:cNvPr id="1" name=""/>
@@ -5825,7 +3733,7 @@
                 <a:ea typeface="Calibri" pitchFamily="34" charset="-122"/>
                 <a:cs typeface="Calibri" pitchFamily="34" charset="-120"/>
               </a:rPr>
-              <a:t>6</a:t>
+              <a:t>5</a:t>
             </a:r>
             <a:endParaRPr lang="en-US" sz="1000" dirty="0"/>
           </a:p>
@@ -5902,9 +3810,9 @@
 </p:sld>
 </file>
 
-<file path=ppt/slides/slide8.xml><?xml version="1.0" encoding="utf-8"?>
+<file path=ppt/slides/slide7.xml><?xml version="1.0" encoding="utf-8"?>
 <p:sld xmlns:a="http://schemas.openxmlformats.org/drawingml/2006/main" xmlns:r="http://schemas.openxmlformats.org/officeDocument/2006/relationships" xmlns:p="http://schemas.openxmlformats.org/presentationml/2006/main">
-  <p:cSld name="Slide 8">
+  <p:cSld name="Slide 7">
     <p:spTree>
       <p:nvGrpSpPr>
         <p:cNvPr id="1" name=""/>
@@ -5952,7 +3860,7 @@
                 <a:ea typeface="Calibri" pitchFamily="34" charset="-122"/>
                 <a:cs typeface="Calibri" pitchFamily="34" charset="-120"/>
               </a:rPr>
-              <a:t>7</a:t>
+              <a:t>6</a:t>
             </a:r>
             <a:endParaRPr lang="en-US" sz="1000" dirty="0"/>
           </a:p>
@@ -6029,9 +3937,9 @@
 </p:sld>
 </file>
 
-<file path=ppt/slides/slide9.xml><?xml version="1.0" encoding="utf-8"?>
+<file path=ppt/slides/slide8.xml><?xml version="1.0" encoding="utf-8"?>
 <p:sld xmlns:a="http://schemas.openxmlformats.org/drawingml/2006/main" xmlns:r="http://schemas.openxmlformats.org/officeDocument/2006/relationships" xmlns:p="http://schemas.openxmlformats.org/presentationml/2006/main">
-  <p:cSld name="Slide 9">
+  <p:cSld name="Slide 8">
     <p:spTree>
       <p:nvGrpSpPr>
         <p:cNvPr id="1" name=""/>
@@ -6079,7 +3987,7 @@
                 <a:ea typeface="Calibri" pitchFamily="34" charset="-122"/>
                 <a:cs typeface="Calibri" pitchFamily="34" charset="-120"/>
               </a:rPr>
-              <a:t>8</a:t>
+              <a:t>7</a:t>
             </a:r>
             <a:endParaRPr lang="en-US" sz="1000" dirty="0"/>
           </a:p>
@@ -6142,6 +4050,133 @@
           <a:xfrm>
             <a:off x="715834" y="960120"/>
             <a:ext cx="10775572" cy="5513832"/>
+          </a:xfrm>
+          <a:prstGeom prst="rect">
+            <a:avLst/>
+          </a:prstGeom>
+        </p:spPr>
+      </p:pic>
+    </p:spTree>
+  </p:cSld>
+  <p:clrMapOvr>
+    <a:masterClrMapping/>
+  </p:clrMapOvr>
+</p:sld>
+</file>
+
+<file path=ppt/slides/slide9.xml><?xml version="1.0" encoding="utf-8"?>
+<p:sld xmlns:a="http://schemas.openxmlformats.org/drawingml/2006/main" xmlns:r="http://schemas.openxmlformats.org/officeDocument/2006/relationships" xmlns:p="http://schemas.openxmlformats.org/presentationml/2006/main">
+  <p:cSld name="Slide 9">
+    <p:spTree>
+      <p:nvGrpSpPr>
+        <p:cNvPr id="1" name=""/>
+        <p:cNvGrpSpPr/>
+        <p:nvPr/>
+      </p:nvGrpSpPr>
+      <p:grpSpPr>
+        <a:xfrm>
+          <a:off x="0" y="0"/>
+          <a:ext cx="0" cy="0"/>
+          <a:chOff x="0" y="0"/>
+          <a:chExt cx="0" cy="0"/>
+        </a:xfrm>
+      </p:grpSpPr>
+      <p:sp>
+        <p:nvSpPr>
+          <p:cNvPr id="2" name="Text 0"/>
+          <p:cNvSpPr txBox="1"/>
+          <p:nvPr/>
+        </p:nvSpPr>
+        <p:spPr>
+          <a:xfrm>
+            <a:off x="11430000" y="6355080"/>
+            <a:ext cx="457200" cy="274320"/>
+          </a:xfrm>
+          <a:prstGeom prst="rect">
+            <a:avLst/>
+          </a:prstGeom>
+          <a:noFill/>
+          <a:ln/>
+        </p:spPr>
+        <p:txBody>
+          <a:bodyPr wrap="square" lIns="0" tIns="0" rIns="0" bIns="0" rtlCol="0" anchor="ctr"/>
+          <a:lstStyle/>
+          <a:p>
+            <a:pPr algn="r" indent="0" marL="0">
+              <a:buNone/>
+            </a:pPr>
+            <a:r>
+              <a:rPr lang="en-US" sz="1000" dirty="0">
+                <a:solidFill>
+                  <a:srgbClr val="6E6E6E"/>
+                </a:solidFill>
+                <a:latin typeface="Calibri" pitchFamily="34" charset="0"/>
+                <a:ea typeface="Calibri" pitchFamily="34" charset="-122"/>
+                <a:cs typeface="Calibri" pitchFamily="34" charset="-120"/>
+              </a:rPr>
+              <a:t>8</a:t>
+            </a:r>
+            <a:endParaRPr lang="en-US" sz="1000" dirty="0"/>
+          </a:p>
+        </p:txBody>
+      </p:sp>
+      <p:sp>
+        <p:nvSpPr>
+          <p:cNvPr id="3" name="Text 1"/>
+          <p:cNvSpPr txBox="1"/>
+          <p:nvPr/>
+        </p:nvSpPr>
+        <p:spPr>
+          <a:xfrm>
+            <a:off x="548640" y="274320"/>
+            <a:ext cx="11064240" cy="475488"/>
+          </a:xfrm>
+          <a:prstGeom prst="rect">
+            <a:avLst/>
+          </a:prstGeom>
+          <a:noFill/>
+          <a:ln/>
+        </p:spPr>
+        <p:txBody>
+          <a:bodyPr wrap="square" lIns="0" tIns="0" rIns="0" bIns="0" rtlCol="0" anchor="ctr"/>
+          <a:lstStyle/>
+          <a:p>
+            <a:pPr indent="0" marL="0">
+              <a:buNone/>
+            </a:pPr>
+            <a:r>
+              <a:rPr lang="en-US" sz="2500" b="1" dirty="0">
+                <a:solidFill>
+                  <a:srgbClr val="000000"/>
+                </a:solidFill>
+                <a:latin typeface="Microsoft YaHei" pitchFamily="34" charset="0"/>
+                <a:ea typeface="Microsoft YaHei" pitchFamily="34" charset="-122"/>
+                <a:cs typeface="Microsoft YaHei" pitchFamily="34" charset="-120"/>
+              </a:rPr>
+              <a:t>白质单核图谱与脱髓鞘病灶分期</a:t>
+            </a:r>
+            <a:endParaRPr lang="en-US" sz="2500" dirty="0"/>
+          </a:p>
+        </p:txBody>
+      </p:sp>
+      <p:pic>
+        <p:nvPicPr>
+          <p:cNvPr id="4" name="Image 0" descr="/home/user/aaa/results/mda5/figs/fig_umap_wm.png">    </p:cNvPr>
+          <p:cNvPicPr>
+            <a:picLocks noChangeAspect="1"/>
+          </p:cNvPicPr>
+          <p:nvPr/>
+        </p:nvPicPr>
+        <p:blipFill>
+          <a:blip r:embed="rId1"/>
+          <a:stretch>
+            <a:fillRect/>
+          </a:stretch>
+        </p:blipFill>
+        <p:spPr>
+          <a:xfrm>
+            <a:off x="411480" y="1067989"/>
+            <a:ext cx="11384280" cy="5298094"/>
           </a:xfrm>
           <a:prstGeom prst="rect">
             <a:avLst/>

</xml_diff>

<commit_message>
Cut the white-matter atlas slide
The UMAP restated what the cell-type slide already establishes, and the lesion
staging beneath it rested on GSE180759's three control donors, a cohort that
also carries a platform confound and a single-library batch island. Supporting
a new claim with the weakest cohort in the set hands it to the examiners.

Eight slides remain, which is the whole argument: the two questions, the
cell-type distribution, the normal compartment contrast, the disease effect in
each compartment, the difference between them, and the dissection confound
that limits what the cortical side can say.

Co-Authored-By: Claude Opus 5 <noreply@anthropic.com>
Claude-Session: https://claude.ai/code/session_01Puq8M8AiJGJDbdbxajvkZL
</commit_message>
<xml_diff>
--- a/results/mda5/MDA5_IFIH1_人脑与MS.pptx
+++ b/results/mda5/MDA5_IFIH1_人脑与MS.pptx
@@ -13,10 +13,9 @@
     <p:sldId id="261" r:id="rId7"/>
     <p:sldId id="262" r:id="rId8"/>
     <p:sldId id="263" r:id="rId9"/>
-    <p:sldId id="264" r:id="rId10"/>
   </p:sldIdLst>
   <p:notesMasterIdLst>
-    <p:notesMasterId r:id="rId11"/>
+    <p:notesMasterId r:id="rId10"/>
   </p:notesMasterIdLst>
   <p:sldSz cx="12192000" cy="6858000"/>
   <p:notesSz cx="6858000" cy="12192000"/>
@@ -1150,94 +1149,6 @@
             <a:fld id="{F7021451-1387-4CA6-816F-3879F97B5CBC}" type="slidenum">
               <a:rPr lang="en-US"/>
               <a:t>8</a:t>
-            </a:fld>
-            <a:endParaRPr lang="en-US"/>
-          </a:p>
-        </p:txBody>
-      </p:sp>
-    </p:spTree>
-    <p:extLst>
-      <p:ext uri="{BB962C8B-B14F-4D97-AF65-F5344CB8AC3E}">
-        <p14:creationId xmlns:p14="http://schemas.microsoft.com/office/powerpoint/2010/main" val="1024086991"/>
-      </p:ext>
-    </p:extLst>
-  </p:cSld>
-  <p:clrMapOvr>
-    <a:masterClrMapping/>
-  </p:clrMapOvr>
-</p:notes>
-</file>
-
-<file path=ppt/notesSlides/notesSlide9.xml><?xml version="1.0" encoding="utf-8"?>
-<p:notes xmlns:a="http://schemas.openxmlformats.org/drawingml/2006/main" xmlns:r="http://schemas.openxmlformats.org/officeDocument/2006/relationships" xmlns:p="http://schemas.openxmlformats.org/presentationml/2006/main">
-  <p:cSld>
-    <p:spTree>
-      <p:nvGrpSpPr>
-        <p:cNvPr id="1" name=""/>
-        <p:cNvGrpSpPr/>
-        <p:nvPr/>
-      </p:nvGrpSpPr>
-      <p:grpSpPr>
-        <a:xfrm>
-          <a:off x="0" y="0"/>
-          <a:ext cx="0" cy="0"/>
-          <a:chOff x="0" y="0"/>
-          <a:chExt cx="0" cy="0"/>
-        </a:xfrm>
-      </p:grpSpPr>
-      <p:sp>
-        <p:nvSpPr>
-          <p:cNvPr id="2" name="Slide Image Placeholder 1"/>
-          <p:cNvSpPr>
-            <a:spLocks noGrp="1" noRot="1" noChangeAspect="1"/>
-          </p:cNvSpPr>
-          <p:nvPr>
-            <p:ph type="sldImg"/>
-          </p:nvPr>
-        </p:nvSpPr>
-        <p:spPr/>
-      </p:sp>
-      <p:sp>
-        <p:nvSpPr>
-          <p:cNvPr id="3" name="Notes Placeholder 2"/>
-          <p:cNvSpPr>
-            <a:spLocks noGrp="1"/>
-          </p:cNvSpPr>
-          <p:nvPr>
-            <p:ph type="body" idx="1"/>
-          </p:nvPr>
-        </p:nvSpPr>
-        <p:spPr/>
-        <p:txBody>
-          <a:bodyPr/>
-          <a:lstStyle/>
-          <a:p>
-            <a:r>
-              <a:rPr lang="en-US" dirty="0"/>
-              <a:t/>
-            </a:r>
-            <a:endParaRPr lang="en-US" dirty="0"/>
-          </a:p>
-        </p:txBody>
-      </p:sp>
-      <p:sp>
-        <p:nvSpPr>
-          <p:cNvPr id="4" name="Slide Number Placeholder 3"/>
-          <p:cNvSpPr>
-            <a:spLocks noGrp="1"/>
-          </p:cNvSpPr>
-          <p:nvPr>
-            <p:ph type="sldNum" sz="quarter" idx="10"/>
-          </p:nvPr>
-        </p:nvSpPr>
-        <p:spPr/>
-        <p:txBody>
-          <a:bodyPr/>
-          <a:lstStyle/>
-          <a:p>
-            <a:fld id="{F7021451-1387-4CA6-816F-3879F97B5CBC}" type="slidenum">
-              <a:rPr lang="en-US"/>
-              <a:t>9</a:t>
             </a:fld>
             <a:endParaRPr lang="en-US"/>
           </a:p>
@@ -4064,133 +3975,6 @@
 </p:sld>
 </file>
 
-<file path=ppt/slides/slide9.xml><?xml version="1.0" encoding="utf-8"?>
-<p:sld xmlns:a="http://schemas.openxmlformats.org/drawingml/2006/main" xmlns:r="http://schemas.openxmlformats.org/officeDocument/2006/relationships" xmlns:p="http://schemas.openxmlformats.org/presentationml/2006/main">
-  <p:cSld name="Slide 9">
-    <p:spTree>
-      <p:nvGrpSpPr>
-        <p:cNvPr id="1" name=""/>
-        <p:cNvGrpSpPr/>
-        <p:nvPr/>
-      </p:nvGrpSpPr>
-      <p:grpSpPr>
-        <a:xfrm>
-          <a:off x="0" y="0"/>
-          <a:ext cx="0" cy="0"/>
-          <a:chOff x="0" y="0"/>
-          <a:chExt cx="0" cy="0"/>
-        </a:xfrm>
-      </p:grpSpPr>
-      <p:sp>
-        <p:nvSpPr>
-          <p:cNvPr id="2" name="Text 0"/>
-          <p:cNvSpPr txBox="1"/>
-          <p:nvPr/>
-        </p:nvSpPr>
-        <p:spPr>
-          <a:xfrm>
-            <a:off x="11430000" y="6355080"/>
-            <a:ext cx="457200" cy="274320"/>
-          </a:xfrm>
-          <a:prstGeom prst="rect">
-            <a:avLst/>
-          </a:prstGeom>
-          <a:noFill/>
-          <a:ln/>
-        </p:spPr>
-        <p:txBody>
-          <a:bodyPr wrap="square" lIns="0" tIns="0" rIns="0" bIns="0" rtlCol="0" anchor="ctr"/>
-          <a:lstStyle/>
-          <a:p>
-            <a:pPr algn="r" indent="0" marL="0">
-              <a:buNone/>
-            </a:pPr>
-            <a:r>
-              <a:rPr lang="en-US" sz="1000" dirty="0">
-                <a:solidFill>
-                  <a:srgbClr val="6E6E6E"/>
-                </a:solidFill>
-                <a:latin typeface="Calibri" pitchFamily="34" charset="0"/>
-                <a:ea typeface="Calibri" pitchFamily="34" charset="-122"/>
-                <a:cs typeface="Calibri" pitchFamily="34" charset="-120"/>
-              </a:rPr>
-              <a:t>8</a:t>
-            </a:r>
-            <a:endParaRPr lang="en-US" sz="1000" dirty="0"/>
-          </a:p>
-        </p:txBody>
-      </p:sp>
-      <p:sp>
-        <p:nvSpPr>
-          <p:cNvPr id="3" name="Text 1"/>
-          <p:cNvSpPr txBox="1"/>
-          <p:nvPr/>
-        </p:nvSpPr>
-        <p:spPr>
-          <a:xfrm>
-            <a:off x="548640" y="274320"/>
-            <a:ext cx="11064240" cy="475488"/>
-          </a:xfrm>
-          <a:prstGeom prst="rect">
-            <a:avLst/>
-          </a:prstGeom>
-          <a:noFill/>
-          <a:ln/>
-        </p:spPr>
-        <p:txBody>
-          <a:bodyPr wrap="square" lIns="0" tIns="0" rIns="0" bIns="0" rtlCol="0" anchor="ctr"/>
-          <a:lstStyle/>
-          <a:p>
-            <a:pPr indent="0" marL="0">
-              <a:buNone/>
-            </a:pPr>
-            <a:r>
-              <a:rPr lang="en-US" sz="2500" b="1" dirty="0">
-                <a:solidFill>
-                  <a:srgbClr val="000000"/>
-                </a:solidFill>
-                <a:latin typeface="Microsoft YaHei" pitchFamily="34" charset="0"/>
-                <a:ea typeface="Microsoft YaHei" pitchFamily="34" charset="-122"/>
-                <a:cs typeface="Microsoft YaHei" pitchFamily="34" charset="-120"/>
-              </a:rPr>
-              <a:t>白质单核图谱与脱髓鞘病灶分期</a:t>
-            </a:r>
-            <a:endParaRPr lang="en-US" sz="2500" dirty="0"/>
-          </a:p>
-        </p:txBody>
-      </p:sp>
-      <p:pic>
-        <p:nvPicPr>
-          <p:cNvPr id="4" name="Image 0" descr="/home/user/aaa/results/mda5/figs/fig_umap_wm.png">    </p:cNvPr>
-          <p:cNvPicPr>
-            <a:picLocks noChangeAspect="1"/>
-          </p:cNvPicPr>
-          <p:nvPr/>
-        </p:nvPicPr>
-        <p:blipFill>
-          <a:blip r:embed="rId1"/>
-          <a:stretch>
-            <a:fillRect/>
-          </a:stretch>
-        </p:blipFill>
-        <p:spPr>
-          <a:xfrm>
-            <a:off x="411480" y="1067989"/>
-            <a:ext cx="11384280" cy="5298094"/>
-          </a:xfrm>
-          <a:prstGeom prst="rect">
-            <a:avLst/>
-          </a:prstGeom>
-        </p:spPr>
-      </p:pic>
-    </p:spTree>
-  </p:cSld>
-  <p:clrMapOvr>
-    <a:masterClrMapping/>
-  </p:clrMapOvr>
-</p:sld>
-</file>
-
 <file path=ppt/theme/theme1.xml><?xml version="1.0" encoding="utf-8"?>
 <a:theme xmlns:a="http://schemas.openxmlformats.org/drawingml/2006/main" name="Office Theme">
   <a:themeElements>

</xml_diff>

<commit_message>
Keep seven slides: restore the atlas, drop the interaction and confound pages
Correcting the previous cut, which removed the wrong slide. The atlas is back.
Out go the compartment-difference intervals and the dissection-composition
page: the first says only that the comparison cannot be resolved at these
donor counts, and the second is a caveat on the cortical slide rather than a
result.

Seven slides: the two questions, the cell-type distribution, the normal
compartment contrast, the disease effect in white matter, the same in cortex,
and the white-matter atlas with lesion staging.

Co-Authored-By: Claude Opus 5 <noreply@anthropic.com>
Claude-Session: https://claude.ai/code/session_01Puq8M8AiJGJDbdbxajvkZL
</commit_message>
<xml_diff>
--- a/results/mda5/MDA5_IFIH1_人脑与MS.pptx
+++ b/results/mda5/MDA5_IFIH1_人脑与MS.pptx
@@ -12,10 +12,9 @@
     <p:sldId id="260" r:id="rId6"/>
     <p:sldId id="261" r:id="rId7"/>
     <p:sldId id="262" r:id="rId8"/>
-    <p:sldId id="263" r:id="rId9"/>
   </p:sldIdLst>
   <p:notesMasterIdLst>
-    <p:notesMasterId r:id="rId10"/>
+    <p:notesMasterId r:id="rId9"/>
   </p:notesMasterIdLst>
   <p:sldSz cx="12192000" cy="6858000"/>
   <p:notesSz cx="6858000" cy="12192000"/>
@@ -1061,94 +1060,6 @@
             <a:fld id="{F7021451-1387-4CA6-816F-3879F97B5CBC}" type="slidenum">
               <a:rPr lang="en-US"/>
               <a:t>7</a:t>
-            </a:fld>
-            <a:endParaRPr lang="en-US"/>
-          </a:p>
-        </p:txBody>
-      </p:sp>
-    </p:spTree>
-    <p:extLst>
-      <p:ext uri="{BB962C8B-B14F-4D97-AF65-F5344CB8AC3E}">
-        <p14:creationId xmlns:p14="http://schemas.microsoft.com/office/powerpoint/2010/main" val="1024086991"/>
-      </p:ext>
-    </p:extLst>
-  </p:cSld>
-  <p:clrMapOvr>
-    <a:masterClrMapping/>
-  </p:clrMapOvr>
-</p:notes>
-</file>
-
-<file path=ppt/notesSlides/notesSlide8.xml><?xml version="1.0" encoding="utf-8"?>
-<p:notes xmlns:a="http://schemas.openxmlformats.org/drawingml/2006/main" xmlns:r="http://schemas.openxmlformats.org/officeDocument/2006/relationships" xmlns:p="http://schemas.openxmlformats.org/presentationml/2006/main">
-  <p:cSld>
-    <p:spTree>
-      <p:nvGrpSpPr>
-        <p:cNvPr id="1" name=""/>
-        <p:cNvGrpSpPr/>
-        <p:nvPr/>
-      </p:nvGrpSpPr>
-      <p:grpSpPr>
-        <a:xfrm>
-          <a:off x="0" y="0"/>
-          <a:ext cx="0" cy="0"/>
-          <a:chOff x="0" y="0"/>
-          <a:chExt cx="0" cy="0"/>
-        </a:xfrm>
-      </p:grpSpPr>
-      <p:sp>
-        <p:nvSpPr>
-          <p:cNvPr id="2" name="Slide Image Placeholder 1"/>
-          <p:cNvSpPr>
-            <a:spLocks noGrp="1" noRot="1" noChangeAspect="1"/>
-          </p:cNvSpPr>
-          <p:nvPr>
-            <p:ph type="sldImg"/>
-          </p:nvPr>
-        </p:nvSpPr>
-        <p:spPr/>
-      </p:sp>
-      <p:sp>
-        <p:nvSpPr>
-          <p:cNvPr id="3" name="Notes Placeholder 2"/>
-          <p:cNvSpPr>
-            <a:spLocks noGrp="1"/>
-          </p:cNvSpPr>
-          <p:nvPr>
-            <p:ph type="body" idx="1"/>
-          </p:nvPr>
-        </p:nvSpPr>
-        <p:spPr/>
-        <p:txBody>
-          <a:bodyPr/>
-          <a:lstStyle/>
-          <a:p>
-            <a:r>
-              <a:rPr lang="en-US" dirty="0"/>
-              <a:t/>
-            </a:r>
-            <a:endParaRPr lang="en-US" dirty="0"/>
-          </a:p>
-        </p:txBody>
-      </p:sp>
-      <p:sp>
-        <p:nvSpPr>
-          <p:cNvPr id="4" name="Slide Number Placeholder 3"/>
-          <p:cNvSpPr>
-            <a:spLocks noGrp="1"/>
-          </p:cNvSpPr>
-          <p:nvPr>
-            <p:ph type="sldNum" sz="quarter" idx="10"/>
-          </p:nvPr>
-        </p:nvSpPr>
-        <p:spPr/>
-        <p:txBody>
-          <a:bodyPr/>
-          <a:lstStyle/>
-          <a:p>
-            <a:fld id="{F7021451-1387-4CA6-816F-3879F97B5CBC}" type="slidenum">
-              <a:rPr lang="en-US"/>
-              <a:t>8</a:t>
             </a:fld>
             <a:endParaRPr lang="en-US"/>
           </a:p>
@@ -3810,7 +3721,7 @@
                 <a:ea typeface="Microsoft YaHei" pitchFamily="34" charset="-122"/>
                 <a:cs typeface="Microsoft YaHei" pitchFamily="34" charset="-120"/>
               </a:rPr>
-              <a:t>两个区域变化幅度之差</a:t>
+              <a:t>白质单核图谱与脱髓鞘病灶分期</a:t>
             </a:r>
             <a:endParaRPr lang="en-US" sz="2500" dirty="0"/>
           </a:p>
@@ -3818,7 +3729,7 @@
       </p:sp>
       <p:pic>
         <p:nvPicPr>
-          <p:cNvPr id="4" name="Image 0" descr="/home/user/aaa/results/mda5/figs/fig_q2_interaction.png">    </p:cNvPr>
+          <p:cNvPr id="4" name="Image 0" descr="/home/user/aaa/results/mda5/figs/fig_umap_wm.png">    </p:cNvPr>
           <p:cNvPicPr>
             <a:picLocks noChangeAspect="1"/>
           </p:cNvPicPr>
@@ -3832,135 +3743,8 @@
         </p:blipFill>
         <p:spPr>
           <a:xfrm>
-            <a:off x="411480" y="1213819"/>
-            <a:ext cx="11384280" cy="5006434"/>
-          </a:xfrm>
-          <a:prstGeom prst="rect">
-            <a:avLst/>
-          </a:prstGeom>
-        </p:spPr>
-      </p:pic>
-    </p:spTree>
-  </p:cSld>
-  <p:clrMapOvr>
-    <a:masterClrMapping/>
-  </p:clrMapOvr>
-</p:sld>
-</file>
-
-<file path=ppt/slides/slide8.xml><?xml version="1.0" encoding="utf-8"?>
-<p:sld xmlns:a="http://schemas.openxmlformats.org/drawingml/2006/main" xmlns:r="http://schemas.openxmlformats.org/officeDocument/2006/relationships" xmlns:p="http://schemas.openxmlformats.org/presentationml/2006/main">
-  <p:cSld name="Slide 8">
-    <p:spTree>
-      <p:nvGrpSpPr>
-        <p:cNvPr id="1" name=""/>
-        <p:cNvGrpSpPr/>
-        <p:nvPr/>
-      </p:nvGrpSpPr>
-      <p:grpSpPr>
-        <a:xfrm>
-          <a:off x="0" y="0"/>
-          <a:ext cx="0" cy="0"/>
-          <a:chOff x="0" y="0"/>
-          <a:chExt cx="0" cy="0"/>
-        </a:xfrm>
-      </p:grpSpPr>
-      <p:sp>
-        <p:nvSpPr>
-          <p:cNvPr id="2" name="Text 0"/>
-          <p:cNvSpPr txBox="1"/>
-          <p:nvPr/>
-        </p:nvSpPr>
-        <p:spPr>
-          <a:xfrm>
-            <a:off x="11430000" y="6355080"/>
-            <a:ext cx="457200" cy="274320"/>
-          </a:xfrm>
-          <a:prstGeom prst="rect">
-            <a:avLst/>
-          </a:prstGeom>
-          <a:noFill/>
-          <a:ln/>
-        </p:spPr>
-        <p:txBody>
-          <a:bodyPr wrap="square" lIns="0" tIns="0" rIns="0" bIns="0" rtlCol="0" anchor="ctr"/>
-          <a:lstStyle/>
-          <a:p>
-            <a:pPr algn="r" indent="0" marL="0">
-              <a:buNone/>
-            </a:pPr>
-            <a:r>
-              <a:rPr lang="en-US" sz="1000" dirty="0">
-                <a:solidFill>
-                  <a:srgbClr val="6E6E6E"/>
-                </a:solidFill>
-                <a:latin typeface="Calibri" pitchFamily="34" charset="0"/>
-                <a:ea typeface="Calibri" pitchFamily="34" charset="-122"/>
-                <a:cs typeface="Calibri" pitchFamily="34" charset="-120"/>
-              </a:rPr>
-              <a:t>7</a:t>
-            </a:r>
-            <a:endParaRPr lang="en-US" sz="1000" dirty="0"/>
-          </a:p>
-        </p:txBody>
-      </p:sp>
-      <p:sp>
-        <p:nvSpPr>
-          <p:cNvPr id="3" name="Text 1"/>
-          <p:cNvSpPr txBox="1"/>
-          <p:nvPr/>
-        </p:nvSpPr>
-        <p:spPr>
-          <a:xfrm>
-            <a:off x="548640" y="274320"/>
-            <a:ext cx="11064240" cy="475488"/>
-          </a:xfrm>
-          <a:prstGeom prst="rect">
-            <a:avLst/>
-          </a:prstGeom>
-          <a:noFill/>
-          <a:ln/>
-        </p:spPr>
-        <p:txBody>
-          <a:bodyPr wrap="square" lIns="0" tIns="0" rIns="0" bIns="0" rtlCol="0" anchor="ctr"/>
-          <a:lstStyle/>
-          <a:p>
-            <a:pPr indent="0" marL="0">
-              <a:buNone/>
-            </a:pPr>
-            <a:r>
-              <a:rPr lang="en-US" sz="2500" b="1" dirty="0">
-                <a:solidFill>
-                  <a:srgbClr val="000000"/>
-                </a:solidFill>
-                <a:latin typeface="Microsoft YaHei" pitchFamily="34" charset="0"/>
-                <a:ea typeface="Microsoft YaHei" pitchFamily="34" charset="-122"/>
-                <a:cs typeface="Microsoft YaHei" pitchFamily="34" charset="-120"/>
-              </a:rPr>
-              <a:t>皮层标本含皮层下白质，MS 取材更深</a:t>
-            </a:r>
-            <a:endParaRPr lang="en-US" sz="2500" dirty="0"/>
-          </a:p>
-        </p:txBody>
-      </p:sp>
-      <p:pic>
-        <p:nvPicPr>
-          <p:cNvPr id="4" name="Image 0" descr="/home/user/aaa/results/mda5/figs/fig_confound.png">    </p:cNvPr>
-          <p:cNvPicPr>
-            <a:picLocks noChangeAspect="1"/>
-          </p:cNvPicPr>
-          <p:nvPr/>
-        </p:nvPicPr>
-        <p:blipFill>
-          <a:blip r:embed="rId1"/>
-          <a:stretch>
-            <a:fillRect/>
-          </a:stretch>
-        </p:blipFill>
-        <p:spPr>
-          <a:xfrm>
-            <a:off x="715834" y="960120"/>
-            <a:ext cx="10775572" cy="5513832"/>
+            <a:off x="411480" y="1067989"/>
+            <a:ext cx="11384280" cy="5298094"/>
           </a:xfrm>
           <a:prstGeom prst="rect">
             <a:avLst/>

</xml_diff>

<commit_message>
Mark significance on every comparison
Stars where the donor-level test reaches significance, ns where it does not,
with the convention printed under each figure. Only two marks survive: the
oligodendrocyte rise in GSE279180 white matter (3.5-fold, **) and, on the
atlas, microglia and endothelium.

On the atlas the comparison is control against the MS stages pooled, not stage
by stage. Three control donors against four per stage puts the smallest
attainable two-sided Mann-Whitney p at 0.057, so a per-stage star is
arithmetically impossible there and its absence would have meant nothing.

Co-Authored-By: Claude Opus 5 <noreply@anthropic.com>
Claude-Session: https://claude.ai/code/session_01Puq8M8AiJGJDbdbxajvkZL
</commit_message>
<xml_diff>
--- a/results/mda5/MDA5_IFIH1_人脑与MS.pptx
+++ b/results/mda5/MDA5_IFIH1_人脑与MS.pptx
@@ -3362,8 +3362,8 @@
         </p:blipFill>
         <p:spPr>
           <a:xfrm>
-            <a:off x="841895" y="960120"/>
-            <a:ext cx="10523449" cy="5513832"/>
+            <a:off x="1024677" y="960120"/>
+            <a:ext cx="10157885" cy="5513832"/>
           </a:xfrm>
           <a:prstGeom prst="rect">
             <a:avLst/>
@@ -3489,8 +3489,8 @@
         </p:blipFill>
         <p:spPr>
           <a:xfrm>
-            <a:off x="650310" y="960120"/>
-            <a:ext cx="10906621" cy="5513832"/>
+            <a:off x="870981" y="960120"/>
+            <a:ext cx="10465278" cy="5513832"/>
           </a:xfrm>
           <a:prstGeom prst="rect">
             <a:avLst/>
@@ -3616,8 +3616,8 @@
         </p:blipFill>
         <p:spPr>
           <a:xfrm>
-            <a:off x="1444400" y="960120"/>
-            <a:ext cx="9318439" cy="5513832"/>
+            <a:off x="1604529" y="960120"/>
+            <a:ext cx="8998183" cy="5513832"/>
           </a:xfrm>
           <a:prstGeom prst="rect">
             <a:avLst/>
@@ -3743,8 +3743,8 @@
         </p:blipFill>
         <p:spPr>
           <a:xfrm>
-            <a:off x="411480" y="1067989"/>
-            <a:ext cx="11384280" cy="5298094"/>
+            <a:off x="496361" y="960120"/>
+            <a:ext cx="11214518" cy="5513832"/>
           </a:xfrm>
           <a:prstGeom prst="rect">
             <a:avLst/>

</xml_diff>

<commit_message>
Put the single-nucleus atlas back, as one row
Eight slides. The atlas returns as the map: nuclei coloured by cell type, then
the same map five times showing one lesion stage each, with IFIH1 level in
place of colour. Control white matter is nearly empty; the chronic-active edge
lights up over the microglia cluster and through the oligodendrocyte body.

Its lower row of donor values is gone. That quantification came from
GSE180759's three controls and the next slide now does the same job on
Macnair's thirteen, so keeping both would have put a weaker measurement of the
same thing beside a stronger one.

Co-Authored-By: Claude Opus 5 <noreply@anthropic.com>
Claude-Session: https://claude.ai/code/session_01Puq8M8AiJGJDbdbxajvkZL
</commit_message>
<xml_diff>
--- a/results/mda5/MDA5_IFIH1_人脑与MS.pptx
+++ b/results/mda5/MDA5_IFIH1_人脑与MS.pptx
@@ -12,9 +12,10 @@
     <p:sldId id="260" r:id="rId6"/>
     <p:sldId id="261" r:id="rId7"/>
     <p:sldId id="262" r:id="rId8"/>
+    <p:sldId id="263" r:id="rId9"/>
   </p:sldIdLst>
   <p:notesMasterIdLst>
-    <p:notesMasterId r:id="rId9"/>
+    <p:notesMasterId r:id="rId10"/>
   </p:notesMasterIdLst>
   <p:sldSz cx="12192000" cy="6858000"/>
   <p:notesSz cx="6858000" cy="12192000"/>
@@ -1060,6 +1061,94 @@
             <a:fld id="{F7021451-1387-4CA6-816F-3879F97B5CBC}" type="slidenum">
               <a:rPr lang="en-US"/>
               <a:t>7</a:t>
+            </a:fld>
+            <a:endParaRPr lang="en-US"/>
+          </a:p>
+        </p:txBody>
+      </p:sp>
+    </p:spTree>
+    <p:extLst>
+      <p:ext uri="{BB962C8B-B14F-4D97-AF65-F5344CB8AC3E}">
+        <p14:creationId xmlns:p14="http://schemas.microsoft.com/office/powerpoint/2010/main" val="1024086991"/>
+      </p:ext>
+    </p:extLst>
+  </p:cSld>
+  <p:clrMapOvr>
+    <a:masterClrMapping/>
+  </p:clrMapOvr>
+</p:notes>
+</file>
+
+<file path=ppt/notesSlides/notesSlide8.xml><?xml version="1.0" encoding="utf-8"?>
+<p:notes xmlns:a="http://schemas.openxmlformats.org/drawingml/2006/main" xmlns:r="http://schemas.openxmlformats.org/officeDocument/2006/relationships" xmlns:p="http://schemas.openxmlformats.org/presentationml/2006/main">
+  <p:cSld>
+    <p:spTree>
+      <p:nvGrpSpPr>
+        <p:cNvPr id="1" name=""/>
+        <p:cNvGrpSpPr/>
+        <p:nvPr/>
+      </p:nvGrpSpPr>
+      <p:grpSpPr>
+        <a:xfrm>
+          <a:off x="0" y="0"/>
+          <a:ext cx="0" cy="0"/>
+          <a:chOff x="0" y="0"/>
+          <a:chExt cx="0" cy="0"/>
+        </a:xfrm>
+      </p:grpSpPr>
+      <p:sp>
+        <p:nvSpPr>
+          <p:cNvPr id="2" name="Slide Image Placeholder 1"/>
+          <p:cNvSpPr>
+            <a:spLocks noGrp="1" noRot="1" noChangeAspect="1"/>
+          </p:cNvSpPr>
+          <p:nvPr>
+            <p:ph type="sldImg"/>
+          </p:nvPr>
+        </p:nvSpPr>
+        <p:spPr/>
+      </p:sp>
+      <p:sp>
+        <p:nvSpPr>
+          <p:cNvPr id="3" name="Notes Placeholder 2"/>
+          <p:cNvSpPr>
+            <a:spLocks noGrp="1"/>
+          </p:cNvSpPr>
+          <p:nvPr>
+            <p:ph type="body" idx="1"/>
+          </p:nvPr>
+        </p:nvSpPr>
+        <p:spPr/>
+        <p:txBody>
+          <a:bodyPr/>
+          <a:lstStyle/>
+          <a:p>
+            <a:r>
+              <a:rPr lang="en-US" dirty="0"/>
+              <a:t/>
+            </a:r>
+            <a:endParaRPr lang="en-US" dirty="0"/>
+          </a:p>
+        </p:txBody>
+      </p:sp>
+      <p:sp>
+        <p:nvSpPr>
+          <p:cNvPr id="4" name="Slide Number Placeholder 3"/>
+          <p:cNvSpPr>
+            <a:spLocks noGrp="1"/>
+          </p:cNvSpPr>
+          <p:nvPr>
+            <p:ph type="sldNum" sz="quarter" idx="10"/>
+          </p:nvPr>
+        </p:nvSpPr>
+        <p:spPr/>
+        <p:txBody>
+          <a:bodyPr/>
+          <a:lstStyle/>
+          <a:p>
+            <a:fld id="{F7021451-1387-4CA6-816F-3879F97B5CBC}" type="slidenum">
+              <a:rPr lang="en-US"/>
+              <a:t>8</a:t>
             </a:fld>
             <a:endParaRPr lang="en-US"/>
           </a:p>
@@ -3721,6 +3810,133 @@
                 <a:ea typeface="Microsoft YaHei" pitchFamily="34" charset="-122"/>
                 <a:cs typeface="Microsoft YaHei" pitchFamily="34" charset="-120"/>
               </a:rPr>
+              <a:t>IFIH1 在白质单核中的分布，按病灶分期</a:t>
+            </a:r>
+            <a:endParaRPr lang="en-US" sz="2500" dirty="0"/>
+          </a:p>
+        </p:txBody>
+      </p:sp>
+      <p:pic>
+        <p:nvPicPr>
+          <p:cNvPr id="4" name="Image 0" descr="/home/user/aaa/results/mda5/figs/fig_umap_wm.png">    </p:cNvPr>
+          <p:cNvPicPr>
+            <a:picLocks noChangeAspect="1"/>
+          </p:cNvPicPr>
+          <p:nvPr/>
+        </p:nvPicPr>
+        <p:blipFill>
+          <a:blip r:embed="rId1"/>
+          <a:stretch>
+            <a:fillRect/>
+          </a:stretch>
+        </p:blipFill>
+        <p:spPr>
+          <a:xfrm>
+            <a:off x="411480" y="1942346"/>
+            <a:ext cx="11384280" cy="3549379"/>
+          </a:xfrm>
+          <a:prstGeom prst="rect">
+            <a:avLst/>
+          </a:prstGeom>
+        </p:spPr>
+      </p:pic>
+    </p:spTree>
+  </p:cSld>
+  <p:clrMapOvr>
+    <a:masterClrMapping/>
+  </p:clrMapOvr>
+</p:sld>
+</file>
+
+<file path=ppt/slides/slide8.xml><?xml version="1.0" encoding="utf-8"?>
+<p:sld xmlns:a="http://schemas.openxmlformats.org/drawingml/2006/main" xmlns:r="http://schemas.openxmlformats.org/officeDocument/2006/relationships" xmlns:p="http://schemas.openxmlformats.org/presentationml/2006/main">
+  <p:cSld name="Slide 8">
+    <p:spTree>
+      <p:nvGrpSpPr>
+        <p:cNvPr id="1" name=""/>
+        <p:cNvGrpSpPr/>
+        <p:nvPr/>
+      </p:nvGrpSpPr>
+      <p:grpSpPr>
+        <a:xfrm>
+          <a:off x="0" y="0"/>
+          <a:ext cx="0" cy="0"/>
+          <a:chOff x="0" y="0"/>
+          <a:chExt cx="0" cy="0"/>
+        </a:xfrm>
+      </p:grpSpPr>
+      <p:sp>
+        <p:nvSpPr>
+          <p:cNvPr id="2" name="Text 0"/>
+          <p:cNvSpPr txBox="1"/>
+          <p:nvPr/>
+        </p:nvSpPr>
+        <p:spPr>
+          <a:xfrm>
+            <a:off x="11430000" y="6355080"/>
+            <a:ext cx="457200" cy="274320"/>
+          </a:xfrm>
+          <a:prstGeom prst="rect">
+            <a:avLst/>
+          </a:prstGeom>
+          <a:noFill/>
+          <a:ln/>
+        </p:spPr>
+        <p:txBody>
+          <a:bodyPr wrap="square" lIns="0" tIns="0" rIns="0" bIns="0" rtlCol="0" anchor="ctr"/>
+          <a:lstStyle/>
+          <a:p>
+            <a:pPr algn="r" indent="0" marL="0">
+              <a:buNone/>
+            </a:pPr>
+            <a:r>
+              <a:rPr lang="en-US" sz="1000" dirty="0">
+                <a:solidFill>
+                  <a:srgbClr val="6E6E6E"/>
+                </a:solidFill>
+                <a:latin typeface="Calibri" pitchFamily="34" charset="0"/>
+                <a:ea typeface="Calibri" pitchFamily="34" charset="-122"/>
+                <a:cs typeface="Calibri" pitchFamily="34" charset="-120"/>
+              </a:rPr>
+              <a:t>7</a:t>
+            </a:r>
+            <a:endParaRPr lang="en-US" sz="1000" dirty="0"/>
+          </a:p>
+        </p:txBody>
+      </p:sp>
+      <p:sp>
+        <p:nvSpPr>
+          <p:cNvPr id="3" name="Text 1"/>
+          <p:cNvSpPr txBox="1"/>
+          <p:nvPr/>
+        </p:nvSpPr>
+        <p:spPr>
+          <a:xfrm>
+            <a:off x="548640" y="274320"/>
+            <a:ext cx="11064240" cy="475488"/>
+          </a:xfrm>
+          <a:prstGeom prst="rect">
+            <a:avLst/>
+          </a:prstGeom>
+          <a:noFill/>
+          <a:ln/>
+        </p:spPr>
+        <p:txBody>
+          <a:bodyPr wrap="square" lIns="0" tIns="0" rIns="0" bIns="0" rtlCol="0" anchor="ctr"/>
+          <a:lstStyle/>
+          <a:p>
+            <a:pPr indent="0" marL="0">
+              <a:buNone/>
+            </a:pPr>
+            <a:r>
+              <a:rPr lang="en-US" sz="2500" b="1" dirty="0">
+                <a:solidFill>
+                  <a:srgbClr val="000000"/>
+                </a:solidFill>
+                <a:latin typeface="Microsoft YaHei" pitchFamily="34" charset="0"/>
+                <a:ea typeface="Microsoft YaHei" pitchFamily="34" charset="-122"/>
+                <a:cs typeface="Microsoft YaHei" pitchFamily="34" charset="-120"/>
+              </a:rPr>
               <a:t>按脱髓鞘病灶分期，每一期与对照比较</a:t>
             </a:r>
             <a:endParaRPr lang="en-US" sz="2500" dirty="0"/>

</xml_diff>

<commit_message>
Reshape the atlas so it fills its slide
One row of six panels made a 3.3:1 strip that sat as a thin band across a
16:9 slide. The map now occupies the left half at full height and the five
stage panels sit in two rows beside it, which brings the figure to 1.9:1 and
fills the frame. Nucleus counts moved into the panel titles, where they no
longer collide with the row beneath.

The atlas and the staging quantification stay on separate slides. They come
from different cohorts, GSE180759 and Macnair 2025, and putting two cohorts
under one title invites the question of which data a given panel shows.

Co-Authored-By: Claude Opus 5 <noreply@anthropic.com>
Claude-Session: https://claude.ai/code/session_01Puq8M8AiJGJDbdbxajvkZL
</commit_message>
<xml_diff>
--- a/results/mda5/MDA5_IFIH1_人脑与MS.pptx
+++ b/results/mda5/MDA5_IFIH1_人脑与MS.pptx
@@ -3832,8 +3832,8 @@
         </p:blipFill>
         <p:spPr>
           <a:xfrm>
-            <a:off x="411480" y="1942346"/>
-            <a:ext cx="11384280" cy="3549379"/>
+            <a:off x="935143" y="960120"/>
+            <a:ext cx="10336955" cy="5513832"/>
           </a:xfrm>
           <a:prstGeom prst="rect">
             <a:avLst/>

</xml_diff>

<commit_message>
Cite the data source in the lower left of every figure
Each figure now names the cohorts it draws on, in the NLM form already used
for the reference list, so a figure lifted out of the deck still says where its
numbers came from.

scripts/mda5/figstyle.py holds the five citations in one place and a source()
helper that places them. Figures drawing on more than one cohort list each on
its own line.

Co-Authored-By: Claude Opus 5 <noreply@anthropic.com>
Claude-Session: https://claude.ai/code/session_01Puq8M8AiJGJDbdbxajvkZL
</commit_message>
<xml_diff>
--- a/results/mda5/MDA5_IFIH1_人脑与MS.pptx
+++ b/results/mda5/MDA5_IFIH1_人脑与MS.pptx
@@ -3324,8 +3324,8 @@
         </p:blipFill>
         <p:spPr>
           <a:xfrm>
-            <a:off x="411480" y="1560792"/>
-            <a:ext cx="11384280" cy="4312488"/>
+            <a:off x="411480" y="1418793"/>
+            <a:ext cx="11384280" cy="4596485"/>
           </a:xfrm>
           <a:prstGeom prst="rect">
             <a:avLst/>
@@ -3451,8 +3451,8 @@
         </p:blipFill>
         <p:spPr>
           <a:xfrm>
-            <a:off x="1024677" y="960120"/>
-            <a:ext cx="10157885" cy="5513832"/>
+            <a:off x="1365895" y="960120"/>
+            <a:ext cx="9475451" cy="5513832"/>
           </a:xfrm>
           <a:prstGeom prst="rect">
             <a:avLst/>
@@ -3578,8 +3578,8 @@
         </p:blipFill>
         <p:spPr>
           <a:xfrm>
-            <a:off x="870981" y="960120"/>
-            <a:ext cx="10465278" cy="5513832"/>
+            <a:off x="1114092" y="960120"/>
+            <a:ext cx="9979056" cy="5513832"/>
           </a:xfrm>
           <a:prstGeom prst="rect">
             <a:avLst/>
@@ -3705,8 +3705,8 @@
         </p:blipFill>
         <p:spPr>
           <a:xfrm>
-            <a:off x="1604529" y="960120"/>
-            <a:ext cx="8998183" cy="5513832"/>
+            <a:off x="1716080" y="960120"/>
+            <a:ext cx="8775080" cy="5513832"/>
           </a:xfrm>
           <a:prstGeom prst="rect">
             <a:avLst/>
@@ -3832,8 +3832,8 @@
         </p:blipFill>
         <p:spPr>
           <a:xfrm>
-            <a:off x="935143" y="960120"/>
-            <a:ext cx="10336955" cy="5513832"/>
+            <a:off x="814806" y="960120"/>
+            <a:ext cx="10577628" cy="5513832"/>
           </a:xfrm>
           <a:prstGeom prst="rect">
             <a:avLst/>
@@ -3959,8 +3959,8 @@
         </p:blipFill>
         <p:spPr>
           <a:xfrm>
-            <a:off x="681975" y="960120"/>
-            <a:ext cx="10843290" cy="5513832"/>
+            <a:off x="411546" y="960120"/>
+            <a:ext cx="11384147" cy="5513832"/>
           </a:xfrm>
           <a:prstGeom prst="rect">
             <a:avLst/>

</xml_diff>